<commit_message>
Scinder la couverture Jacoco par type de test (JUnit vs Cucumber)
mvn test genere desormais trois rapports (jacoco-report-junit,
jacoco-report-cucumber, jacoco-report global) au lieu d'un seul, en
fusionnant l'agent -javaagent de jacoco-maven-plugin avec les donnees
separees de l'extension quarkus-jacoco (code execute dans le
QuarkusClassLoader). Script coverage-summary.sh, DESCRIPTION.md et la
presentation mis a jour avec les vraies mesures (JUnit et Cucumber
couvrent des lignes presque disjointes).

Co-Authored-By: Claude Sonnet 5 <noreply@anthropic.com>
Claude-Session: https://claude.ai/code/session_01UJ8K2KSjB3mCiTjCx3LvFL
</commit_message>
<xml_diff>
--- a/presentation/couverture-code-conference.pptx
+++ b/presentation/couverture-code-conference.pptx
@@ -10673,21 +10673,193 @@
                 </a:solidFill>
                 <a:latin typeface="Calibri"/>
               </a:rPr>
-              <a:t>Mesure réelle, extraite du build — couverture de lignes par classe</a:t>
-            </a:r>
-          </a:p>
-        </p:txBody>
-      </p:sp>
-      <p:sp>
-        <p:nvSpPr>
-          <p:cNvPr id="6" name="TextBox 5"/>
+              <a:t>Mesure réelle, extraite du build — couverture de lignes, JUnit contre Cucumber</a:t>
+            </a:r>
+          </a:p>
+        </p:txBody>
+      </p:sp>
+      <p:sp>
+        <p:nvSpPr>
+          <p:cNvPr id="6" name="Rectangle 5"/>
+          <p:cNvSpPr/>
+          <p:nvPr/>
+        </p:nvSpPr>
+        <p:spPr>
+          <a:xfrm>
+            <a:off x="822960" y="1874519"/>
+            <a:ext cx="292608" cy="164592"/>
+          </a:xfrm>
+          <a:prstGeom prst="rect">
+            <a:avLst/>
+          </a:prstGeom>
+          <a:solidFill>
+            <a:srgbClr val="C79A52"/>
+          </a:solidFill>
+          <a:ln>
+            <a:noFill/>
+          </a:ln>
+          <a:effectLst/>
+        </p:spPr>
+        <p:style>
+          <a:lnRef idx="1">
+            <a:schemeClr val="accent1"/>
+          </a:lnRef>
+          <a:fillRef idx="3">
+            <a:schemeClr val="accent1"/>
+          </a:fillRef>
+          <a:effectRef idx="2">
+            <a:schemeClr val="accent1"/>
+          </a:effectRef>
+          <a:fontRef idx="minor">
+            <a:schemeClr val="lt1"/>
+          </a:fontRef>
+        </p:style>
+        <p:txBody>
+          <a:bodyPr rtlCol="0" anchor="ctr"/>
+          <a:lstStyle/>
+          <a:p>
+            <a:pPr algn="ctr"/>
+          </a:p>
+        </p:txBody>
+      </p:sp>
+      <p:sp>
+        <p:nvSpPr>
+          <p:cNvPr id="7" name="TextBox 6"/>
           <p:cNvSpPr txBox="1"/>
           <p:nvPr/>
         </p:nvSpPr>
         <p:spPr>
           <a:xfrm>
-            <a:off x="822960" y="2039112"/>
-            <a:ext cx="2331720" cy="365760"/>
+            <a:off x="1188720" y="1847087"/>
+            <a:ext cx="1828800" cy="274320"/>
+          </a:xfrm>
+          <a:prstGeom prst="rect">
+            <a:avLst/>
+          </a:prstGeom>
+          <a:noFill/>
+        </p:spPr>
+        <p:txBody>
+          <a:bodyPr wrap="square" anchor="t" lIns="0" rIns="0" tIns="0" bIns="0">
+            <a:spAutoFit/>
+          </a:bodyPr>
+          <a:lstStyle/>
+          <a:p>
+            <a:pPr algn="l">
+              <a:lnSpc>
+                <a:spcPct val="100000"/>
+              </a:lnSpc>
+              <a:spcAft>
+                <a:spcPts val="0"/>
+              </a:spcAft>
+            </a:pPr>
+            <a:r>
+              <a:rPr sz="1200" b="1" i="0">
+                <a:solidFill>
+                  <a:srgbClr val="162844"/>
+                </a:solidFill>
+                <a:latin typeface="Calibri"/>
+              </a:rPr>
+              <a:t>JUnit (unitaire)</a:t>
+            </a:r>
+          </a:p>
+        </p:txBody>
+      </p:sp>
+      <p:sp>
+        <p:nvSpPr>
+          <p:cNvPr id="8" name="Rectangle 7"/>
+          <p:cNvSpPr/>
+          <p:nvPr/>
+        </p:nvSpPr>
+        <p:spPr>
+          <a:xfrm>
+            <a:off x="3017520" y="1874519"/>
+            <a:ext cx="292608" cy="164592"/>
+          </a:xfrm>
+          <a:prstGeom prst="rect">
+            <a:avLst/>
+          </a:prstGeom>
+          <a:solidFill>
+            <a:srgbClr val="5C8C86"/>
+          </a:solidFill>
+          <a:ln>
+            <a:noFill/>
+          </a:ln>
+          <a:effectLst/>
+        </p:spPr>
+        <p:style>
+          <a:lnRef idx="1">
+            <a:schemeClr val="accent1"/>
+          </a:lnRef>
+          <a:fillRef idx="3">
+            <a:schemeClr val="accent1"/>
+          </a:fillRef>
+          <a:effectRef idx="2">
+            <a:schemeClr val="accent1"/>
+          </a:effectRef>
+          <a:fontRef idx="minor">
+            <a:schemeClr val="lt1"/>
+          </a:fontRef>
+        </p:style>
+        <p:txBody>
+          <a:bodyPr rtlCol="0" anchor="ctr"/>
+          <a:lstStyle/>
+          <a:p>
+            <a:pPr algn="ctr"/>
+          </a:p>
+        </p:txBody>
+      </p:sp>
+      <p:sp>
+        <p:nvSpPr>
+          <p:cNvPr id="9" name="TextBox 8"/>
+          <p:cNvSpPr txBox="1"/>
+          <p:nvPr/>
+        </p:nvSpPr>
+        <p:spPr>
+          <a:xfrm>
+            <a:off x="3383280" y="1847087"/>
+            <a:ext cx="2743200" cy="274320"/>
+          </a:xfrm>
+          <a:prstGeom prst="rect">
+            <a:avLst/>
+          </a:prstGeom>
+          <a:noFill/>
+        </p:spPr>
+        <p:txBody>
+          <a:bodyPr wrap="square" anchor="t" lIns="0" rIns="0" tIns="0" bIns="0">
+            <a:spAutoFit/>
+          </a:bodyPr>
+          <a:lstStyle/>
+          <a:p>
+            <a:pPr algn="l">
+              <a:lnSpc>
+                <a:spcPct val="100000"/>
+              </a:lnSpc>
+              <a:spcAft>
+                <a:spcPts val="0"/>
+              </a:spcAft>
+            </a:pPr>
+            <a:r>
+              <a:rPr sz="1200" b="1" i="0">
+                <a:solidFill>
+                  <a:srgbClr val="162844"/>
+                </a:solidFill>
+                <a:latin typeface="Calibri"/>
+              </a:rPr>
+              <a:t>Cucumber (intégration)</a:t>
+            </a:r>
+          </a:p>
+        </p:txBody>
+      </p:sp>
+      <p:sp>
+        <p:nvSpPr>
+          <p:cNvPr id="10" name="TextBox 9"/>
+          <p:cNvSpPr txBox="1"/>
+          <p:nvPr/>
+        </p:nvSpPr>
+        <p:spPr>
+          <a:xfrm>
+            <a:off x="822960" y="2441448"/>
+            <a:ext cx="2423160" cy="365760"/>
           </a:xfrm>
           <a:prstGeom prst="rect">
             <a:avLst/>
@@ -10715,21 +10887,21 @@
                 </a:solidFill>
                 <a:latin typeface="Calibri"/>
               </a:rPr>
-              <a:t>RecurrenceRequest (DTO)</a:t>
-            </a:r>
-          </a:p>
-        </p:txBody>
-      </p:sp>
-      <p:sp>
-        <p:nvSpPr>
-          <p:cNvPr id="7" name="Rectangle 6"/>
+              <a:t>CalendarResource</a:t>
+            </a:r>
+          </a:p>
+        </p:txBody>
+      </p:sp>
+      <p:sp>
+        <p:nvSpPr>
+          <p:cNvPr id="11" name="Rectangle 10"/>
           <p:cNvSpPr/>
           <p:nvPr/>
         </p:nvSpPr>
         <p:spPr>
           <a:xfrm>
-            <a:off x="3291840" y="2011680"/>
-            <a:ext cx="7406640" cy="310896"/>
+            <a:off x="3383280" y="2331720"/>
+            <a:ext cx="7315200" cy="201168"/>
           </a:xfrm>
           <a:prstGeom prst="rect">
             <a:avLst/>
@@ -10766,20 +10938,20 @@
       </p:sp>
       <p:sp>
         <p:nvSpPr>
-          <p:cNvPr id="8" name="Rectangle 7"/>
+          <p:cNvPr id="12" name="Rectangle 11"/>
           <p:cNvSpPr/>
           <p:nvPr/>
         </p:nvSpPr>
         <p:spPr>
           <a:xfrm>
-            <a:off x="3291840" y="2011680"/>
-            <a:ext cx="148132" cy="310896"/>
-          </a:xfrm>
-          <a:prstGeom prst="rect">
-            <a:avLst/>
-          </a:prstGeom>
-          <a:solidFill>
-            <a:srgbClr val="BF6F5D"/>
+            <a:off x="3383280" y="2331720"/>
+            <a:ext cx="73152" cy="201168"/>
+          </a:xfrm>
+          <a:prstGeom prst="rect">
+            <a:avLst/>
+          </a:prstGeom>
+          <a:solidFill>
+            <a:srgbClr val="C79A52"/>
           </a:solidFill>
           <a:ln>
             <a:noFill/>
@@ -10810,14 +10982,14 @@
       </p:sp>
       <p:sp>
         <p:nvSpPr>
-          <p:cNvPr id="9" name="TextBox 8"/>
+          <p:cNvPr id="13" name="TextBox 12"/>
           <p:cNvSpPr txBox="1"/>
           <p:nvPr/>
         </p:nvSpPr>
         <p:spPr>
           <a:xfrm>
-            <a:off x="10789920" y="2029968"/>
-            <a:ext cx="640080" cy="320040"/>
+            <a:off x="10789920" y="2313432"/>
+            <a:ext cx="640080" cy="274320"/>
           </a:xfrm>
           <a:prstGeom prst="rect">
             <a:avLst/>
@@ -10839,7 +11011,7 @@
               </a:spcAft>
             </a:pPr>
             <a:r>
-              <a:rPr sz="1250" b="1" i="0">
+              <a:rPr sz="1150" b="1" i="0">
                 <a:solidFill>
                   <a:srgbClr val="162844"/>
                 </a:solidFill>
@@ -10852,14 +11024,144 @@
       </p:sp>
       <p:sp>
         <p:nvSpPr>
-          <p:cNvPr id="10" name="TextBox 9"/>
+          <p:cNvPr id="14" name="Rectangle 13"/>
+          <p:cNvSpPr/>
+          <p:nvPr/>
+        </p:nvSpPr>
+        <p:spPr>
+          <a:xfrm>
+            <a:off x="3383280" y="2587752"/>
+            <a:ext cx="7315200" cy="201168"/>
+          </a:xfrm>
+          <a:prstGeom prst="rect">
+            <a:avLst/>
+          </a:prstGeom>
+          <a:solidFill>
+            <a:srgbClr val="EAE6DA"/>
+          </a:solidFill>
+          <a:ln>
+            <a:noFill/>
+          </a:ln>
+          <a:effectLst/>
+        </p:spPr>
+        <p:style>
+          <a:lnRef idx="1">
+            <a:schemeClr val="accent1"/>
+          </a:lnRef>
+          <a:fillRef idx="3">
+            <a:schemeClr val="accent1"/>
+          </a:fillRef>
+          <a:effectRef idx="2">
+            <a:schemeClr val="accent1"/>
+          </a:effectRef>
+          <a:fontRef idx="minor">
+            <a:schemeClr val="lt1"/>
+          </a:fontRef>
+        </p:style>
+        <p:txBody>
+          <a:bodyPr rtlCol="0" anchor="ctr"/>
+          <a:lstStyle/>
+          <a:p>
+            <a:pPr algn="ctr"/>
+          </a:p>
+        </p:txBody>
+      </p:sp>
+      <p:sp>
+        <p:nvSpPr>
+          <p:cNvPr id="15" name="Rectangle 14"/>
+          <p:cNvSpPr/>
+          <p:nvPr/>
+        </p:nvSpPr>
+        <p:spPr>
+          <a:xfrm>
+            <a:off x="3383280" y="2587752"/>
+            <a:ext cx="4242816" cy="201168"/>
+          </a:xfrm>
+          <a:prstGeom prst="rect">
+            <a:avLst/>
+          </a:prstGeom>
+          <a:solidFill>
+            <a:srgbClr val="5C8C86"/>
+          </a:solidFill>
+          <a:ln>
+            <a:noFill/>
+          </a:ln>
+          <a:effectLst/>
+        </p:spPr>
+        <p:style>
+          <a:lnRef idx="1">
+            <a:schemeClr val="accent1"/>
+          </a:lnRef>
+          <a:fillRef idx="3">
+            <a:schemeClr val="accent1"/>
+          </a:fillRef>
+          <a:effectRef idx="2">
+            <a:schemeClr val="accent1"/>
+          </a:effectRef>
+          <a:fontRef idx="minor">
+            <a:schemeClr val="lt1"/>
+          </a:fontRef>
+        </p:style>
+        <p:txBody>
+          <a:bodyPr rtlCol="0" anchor="ctr"/>
+          <a:lstStyle/>
+          <a:p>
+            <a:pPr algn="ctr"/>
+          </a:p>
+        </p:txBody>
+      </p:sp>
+      <p:sp>
+        <p:nvSpPr>
+          <p:cNvPr id="16" name="TextBox 15"/>
           <p:cNvSpPr txBox="1"/>
           <p:nvPr/>
         </p:nvSpPr>
         <p:spPr>
           <a:xfrm>
-            <a:off x="822960" y="2514600"/>
-            <a:ext cx="2331720" cy="365760"/>
+            <a:off x="10789920" y="2569464"/>
+            <a:ext cx="640080" cy="274320"/>
+          </a:xfrm>
+          <a:prstGeom prst="rect">
+            <a:avLst/>
+          </a:prstGeom>
+          <a:noFill/>
+        </p:spPr>
+        <p:txBody>
+          <a:bodyPr wrap="square" anchor="t" lIns="0" rIns="0" tIns="0" bIns="0">
+            <a:spAutoFit/>
+          </a:bodyPr>
+          <a:lstStyle/>
+          <a:p>
+            <a:pPr algn="l">
+              <a:lnSpc>
+                <a:spcPct val="100000"/>
+              </a:lnSpc>
+              <a:spcAft>
+                <a:spcPts val="0"/>
+              </a:spcAft>
+            </a:pPr>
+            <a:r>
+              <a:rPr sz="1150" b="1" i="0">
+                <a:solidFill>
+                  <a:srgbClr val="162844"/>
+                </a:solidFill>
+                <a:latin typeface="Calibri"/>
+              </a:rPr>
+              <a:t>58%</a:t>
+            </a:r>
+          </a:p>
+        </p:txBody>
+      </p:sp>
+      <p:sp>
+        <p:nvSpPr>
+          <p:cNvPr id="17" name="TextBox 16"/>
+          <p:cNvSpPr txBox="1"/>
+          <p:nvPr/>
+        </p:nvSpPr>
+        <p:spPr>
+          <a:xfrm>
+            <a:off x="822960" y="3063240"/>
+            <a:ext cx="2423160" cy="365760"/>
           </a:xfrm>
           <a:prstGeom prst="rect">
             <a:avLst/>
@@ -10887,21 +11189,21 @@
                 </a:solidFill>
                 <a:latin typeface="Calibri"/>
               </a:rPr>
-              <a:t>CalendarResource</a:t>
-            </a:r>
-          </a:p>
-        </p:txBody>
-      </p:sp>
-      <p:sp>
-        <p:nvSpPr>
-          <p:cNvPr id="11" name="Rectangle 10"/>
+              <a:t>HolidayService</a:t>
+            </a:r>
+          </a:p>
+        </p:txBody>
+      </p:sp>
+      <p:sp>
+        <p:nvSpPr>
+          <p:cNvPr id="18" name="Rectangle 17"/>
           <p:cNvSpPr/>
           <p:nvPr/>
         </p:nvSpPr>
         <p:spPr>
           <a:xfrm>
-            <a:off x="3291840" y="2487168"/>
-            <a:ext cx="7406640" cy="310896"/>
+            <a:off x="3383280" y="2953512"/>
+            <a:ext cx="7315200" cy="201168"/>
           </a:xfrm>
           <a:prstGeom prst="rect">
             <a:avLst/>
@@ -10938,20 +11240,20 @@
       </p:sp>
       <p:sp>
         <p:nvSpPr>
-          <p:cNvPr id="12" name="Rectangle 11"/>
+          <p:cNvPr id="19" name="Rectangle 18"/>
           <p:cNvSpPr/>
           <p:nvPr/>
         </p:nvSpPr>
         <p:spPr>
           <a:xfrm>
-            <a:off x="3291840" y="2487168"/>
-            <a:ext cx="4295851" cy="310896"/>
-          </a:xfrm>
-          <a:prstGeom prst="rect">
-            <a:avLst/>
-          </a:prstGeom>
-          <a:solidFill>
-            <a:srgbClr val="BF6F5D"/>
+            <a:off x="3383280" y="2953512"/>
+            <a:ext cx="73152" cy="201168"/>
+          </a:xfrm>
+          <a:prstGeom prst="rect">
+            <a:avLst/>
+          </a:prstGeom>
+          <a:solidFill>
+            <a:srgbClr val="C79A52"/>
           </a:solidFill>
           <a:ln>
             <a:noFill/>
@@ -10982,14 +11284,14 @@
       </p:sp>
       <p:sp>
         <p:nvSpPr>
-          <p:cNvPr id="13" name="TextBox 12"/>
+          <p:cNvPr id="20" name="TextBox 19"/>
           <p:cNvSpPr txBox="1"/>
           <p:nvPr/>
         </p:nvSpPr>
         <p:spPr>
           <a:xfrm>
-            <a:off x="10789920" y="2505456"/>
-            <a:ext cx="640080" cy="320040"/>
+            <a:off x="10789920" y="2935224"/>
+            <a:ext cx="640080" cy="274320"/>
           </a:xfrm>
           <a:prstGeom prst="rect">
             <a:avLst/>
@@ -11011,27 +11313,157 @@
               </a:spcAft>
             </a:pPr>
             <a:r>
-              <a:rPr sz="1250" b="1" i="0">
+              <a:rPr sz="1150" b="1" i="0">
                 <a:solidFill>
                   <a:srgbClr val="162844"/>
                 </a:solidFill>
                 <a:latin typeface="Calibri"/>
               </a:rPr>
-              <a:t>58%</a:t>
-            </a:r>
-          </a:p>
-        </p:txBody>
-      </p:sp>
-      <p:sp>
-        <p:nvSpPr>
-          <p:cNvPr id="14" name="TextBox 13"/>
+              <a:t>0%</a:t>
+            </a:r>
+          </a:p>
+        </p:txBody>
+      </p:sp>
+      <p:sp>
+        <p:nvSpPr>
+          <p:cNvPr id="21" name="Rectangle 20"/>
+          <p:cNvSpPr/>
+          <p:nvPr/>
+        </p:nvSpPr>
+        <p:spPr>
+          <a:xfrm>
+            <a:off x="3383280" y="3209544"/>
+            <a:ext cx="7315200" cy="201168"/>
+          </a:xfrm>
+          <a:prstGeom prst="rect">
+            <a:avLst/>
+          </a:prstGeom>
+          <a:solidFill>
+            <a:srgbClr val="EAE6DA"/>
+          </a:solidFill>
+          <a:ln>
+            <a:noFill/>
+          </a:ln>
+          <a:effectLst/>
+        </p:spPr>
+        <p:style>
+          <a:lnRef idx="1">
+            <a:schemeClr val="accent1"/>
+          </a:lnRef>
+          <a:fillRef idx="3">
+            <a:schemeClr val="accent1"/>
+          </a:fillRef>
+          <a:effectRef idx="2">
+            <a:schemeClr val="accent1"/>
+          </a:effectRef>
+          <a:fontRef idx="minor">
+            <a:schemeClr val="lt1"/>
+          </a:fontRef>
+        </p:style>
+        <p:txBody>
+          <a:bodyPr rtlCol="0" anchor="ctr"/>
+          <a:lstStyle/>
+          <a:p>
+            <a:pPr algn="ctr"/>
+          </a:p>
+        </p:txBody>
+      </p:sp>
+      <p:sp>
+        <p:nvSpPr>
+          <p:cNvPr id="22" name="Rectangle 21"/>
+          <p:cNvSpPr/>
+          <p:nvPr/>
+        </p:nvSpPr>
+        <p:spPr>
+          <a:xfrm>
+            <a:off x="3383280" y="3209544"/>
+            <a:ext cx="6803136" cy="201168"/>
+          </a:xfrm>
+          <a:prstGeom prst="rect">
+            <a:avLst/>
+          </a:prstGeom>
+          <a:solidFill>
+            <a:srgbClr val="5C8C86"/>
+          </a:solidFill>
+          <a:ln>
+            <a:noFill/>
+          </a:ln>
+          <a:effectLst/>
+        </p:spPr>
+        <p:style>
+          <a:lnRef idx="1">
+            <a:schemeClr val="accent1"/>
+          </a:lnRef>
+          <a:fillRef idx="3">
+            <a:schemeClr val="accent1"/>
+          </a:fillRef>
+          <a:effectRef idx="2">
+            <a:schemeClr val="accent1"/>
+          </a:effectRef>
+          <a:fontRef idx="minor">
+            <a:schemeClr val="lt1"/>
+          </a:fontRef>
+        </p:style>
+        <p:txBody>
+          <a:bodyPr rtlCol="0" anchor="ctr"/>
+          <a:lstStyle/>
+          <a:p>
+            <a:pPr algn="ctr"/>
+          </a:p>
+        </p:txBody>
+      </p:sp>
+      <p:sp>
+        <p:nvSpPr>
+          <p:cNvPr id="23" name="TextBox 22"/>
           <p:cNvSpPr txBox="1"/>
           <p:nvPr/>
         </p:nvSpPr>
         <p:spPr>
           <a:xfrm>
-            <a:off x="822960" y="2990088"/>
-            <a:ext cx="2331720" cy="365760"/>
+            <a:off x="10789920" y="3191256"/>
+            <a:ext cx="640080" cy="274320"/>
+          </a:xfrm>
+          <a:prstGeom prst="rect">
+            <a:avLst/>
+          </a:prstGeom>
+          <a:noFill/>
+        </p:spPr>
+        <p:txBody>
+          <a:bodyPr wrap="square" anchor="t" lIns="0" rIns="0" tIns="0" bIns="0">
+            <a:spAutoFit/>
+          </a:bodyPr>
+          <a:lstStyle/>
+          <a:p>
+            <a:pPr algn="l">
+              <a:lnSpc>
+                <a:spcPct val="100000"/>
+              </a:lnSpc>
+              <a:spcAft>
+                <a:spcPts val="0"/>
+              </a:spcAft>
+            </a:pPr>
+            <a:r>
+              <a:rPr sz="1150" b="1" i="0">
+                <a:solidFill>
+                  <a:srgbClr val="162844"/>
+                </a:solidFill>
+                <a:latin typeface="Calibri"/>
+              </a:rPr>
+              <a:t>93%</a:t>
+            </a:r>
+          </a:p>
+        </p:txBody>
+      </p:sp>
+      <p:sp>
+        <p:nvSpPr>
+          <p:cNvPr id="24" name="TextBox 23"/>
+          <p:cNvSpPr txBox="1"/>
+          <p:nvPr/>
+        </p:nvSpPr>
+        <p:spPr>
+          <a:xfrm>
+            <a:off x="822960" y="3685032"/>
+            <a:ext cx="2423160" cy="365760"/>
           </a:xfrm>
           <a:prstGeom prst="rect">
             <a:avLst/>
@@ -11059,21 +11491,21 @@
                 </a:solidFill>
                 <a:latin typeface="Calibri"/>
               </a:rPr>
-              <a:t>Event (modèle)</a:t>
-            </a:r>
-          </a:p>
-        </p:txBody>
-      </p:sp>
-      <p:sp>
-        <p:nvSpPr>
-          <p:cNvPr id="15" name="Rectangle 14"/>
+              <a:t>RecurrenceService</a:t>
+            </a:r>
+          </a:p>
+        </p:txBody>
+      </p:sp>
+      <p:sp>
+        <p:nvSpPr>
+          <p:cNvPr id="25" name="Rectangle 24"/>
           <p:cNvSpPr/>
           <p:nvPr/>
         </p:nvSpPr>
         <p:spPr>
           <a:xfrm>
-            <a:off x="3291840" y="2962656"/>
-            <a:ext cx="7406640" cy="310896"/>
+            <a:off x="3383280" y="3575304"/>
+            <a:ext cx="7315200" cy="201168"/>
           </a:xfrm>
           <a:prstGeom prst="rect">
             <a:avLst/>
@@ -11110,14 +11542,14 @@
       </p:sp>
       <p:sp>
         <p:nvSpPr>
-          <p:cNvPr id="16" name="Rectangle 15"/>
+          <p:cNvPr id="26" name="Rectangle 25"/>
           <p:cNvSpPr/>
           <p:nvPr/>
         </p:nvSpPr>
         <p:spPr>
           <a:xfrm>
-            <a:off x="3291840" y="2962656"/>
-            <a:ext cx="4962448" cy="310896"/>
+            <a:off x="3383280" y="3575304"/>
+            <a:ext cx="5705856" cy="201168"/>
           </a:xfrm>
           <a:prstGeom prst="rect">
             <a:avLst/>
@@ -11154,14 +11586,14 @@
       </p:sp>
       <p:sp>
         <p:nvSpPr>
-          <p:cNvPr id="17" name="TextBox 16"/>
+          <p:cNvPr id="27" name="TextBox 26"/>
           <p:cNvSpPr txBox="1"/>
           <p:nvPr/>
         </p:nvSpPr>
         <p:spPr>
           <a:xfrm>
-            <a:off x="10789920" y="2980944"/>
-            <a:ext cx="640080" cy="320040"/>
+            <a:off x="10789920" y="3557016"/>
+            <a:ext cx="640080" cy="274320"/>
           </a:xfrm>
           <a:prstGeom prst="rect">
             <a:avLst/>
@@ -11183,27 +11615,157 @@
               </a:spcAft>
             </a:pPr>
             <a:r>
-              <a:rPr sz="1250" b="1" i="0">
+              <a:rPr sz="1150" b="1" i="0">
                 <a:solidFill>
                   <a:srgbClr val="162844"/>
                 </a:solidFill>
                 <a:latin typeface="Calibri"/>
               </a:rPr>
-              <a:t>67%</a:t>
-            </a:r>
-          </a:p>
-        </p:txBody>
-      </p:sp>
-      <p:sp>
-        <p:nvSpPr>
-          <p:cNvPr id="18" name="TextBox 17"/>
+              <a:t>78%</a:t>
+            </a:r>
+          </a:p>
+        </p:txBody>
+      </p:sp>
+      <p:sp>
+        <p:nvSpPr>
+          <p:cNvPr id="28" name="Rectangle 27"/>
+          <p:cNvSpPr/>
+          <p:nvPr/>
+        </p:nvSpPr>
+        <p:spPr>
+          <a:xfrm>
+            <a:off x="3383280" y="3831336"/>
+            <a:ext cx="7315200" cy="201168"/>
+          </a:xfrm>
+          <a:prstGeom prst="rect">
+            <a:avLst/>
+          </a:prstGeom>
+          <a:solidFill>
+            <a:srgbClr val="EAE6DA"/>
+          </a:solidFill>
+          <a:ln>
+            <a:noFill/>
+          </a:ln>
+          <a:effectLst/>
+        </p:spPr>
+        <p:style>
+          <a:lnRef idx="1">
+            <a:schemeClr val="accent1"/>
+          </a:lnRef>
+          <a:fillRef idx="3">
+            <a:schemeClr val="accent1"/>
+          </a:fillRef>
+          <a:effectRef idx="2">
+            <a:schemeClr val="accent1"/>
+          </a:effectRef>
+          <a:fontRef idx="minor">
+            <a:schemeClr val="lt1"/>
+          </a:fontRef>
+        </p:style>
+        <p:txBody>
+          <a:bodyPr rtlCol="0" anchor="ctr"/>
+          <a:lstStyle/>
+          <a:p>
+            <a:pPr algn="ctr"/>
+          </a:p>
+        </p:txBody>
+      </p:sp>
+      <p:sp>
+        <p:nvSpPr>
+          <p:cNvPr id="29" name="Rectangle 28"/>
+          <p:cNvSpPr/>
+          <p:nvPr/>
+        </p:nvSpPr>
+        <p:spPr>
+          <a:xfrm>
+            <a:off x="3383280" y="3831336"/>
+            <a:ext cx="292608" cy="201168"/>
+          </a:xfrm>
+          <a:prstGeom prst="rect">
+            <a:avLst/>
+          </a:prstGeom>
+          <a:solidFill>
+            <a:srgbClr val="5C8C86"/>
+          </a:solidFill>
+          <a:ln>
+            <a:noFill/>
+          </a:ln>
+          <a:effectLst/>
+        </p:spPr>
+        <p:style>
+          <a:lnRef idx="1">
+            <a:schemeClr val="accent1"/>
+          </a:lnRef>
+          <a:fillRef idx="3">
+            <a:schemeClr val="accent1"/>
+          </a:fillRef>
+          <a:effectRef idx="2">
+            <a:schemeClr val="accent1"/>
+          </a:effectRef>
+          <a:fontRef idx="minor">
+            <a:schemeClr val="lt1"/>
+          </a:fontRef>
+        </p:style>
+        <p:txBody>
+          <a:bodyPr rtlCol="0" anchor="ctr"/>
+          <a:lstStyle/>
+          <a:p>
+            <a:pPr algn="ctr"/>
+          </a:p>
+        </p:txBody>
+      </p:sp>
+      <p:sp>
+        <p:nvSpPr>
+          <p:cNvPr id="30" name="TextBox 29"/>
           <p:cNvSpPr txBox="1"/>
           <p:nvPr/>
         </p:nvSpPr>
         <p:spPr>
           <a:xfrm>
-            <a:off x="822960" y="3465576"/>
-            <a:ext cx="2331720" cy="365760"/>
+            <a:off x="10789920" y="3813048"/>
+            <a:ext cx="640080" cy="274320"/>
+          </a:xfrm>
+          <a:prstGeom prst="rect">
+            <a:avLst/>
+          </a:prstGeom>
+          <a:noFill/>
+        </p:spPr>
+        <p:txBody>
+          <a:bodyPr wrap="square" anchor="t" lIns="0" rIns="0" tIns="0" bIns="0">
+            <a:spAutoFit/>
+          </a:bodyPr>
+          <a:lstStyle/>
+          <a:p>
+            <a:pPr algn="l">
+              <a:lnSpc>
+                <a:spcPct val="100000"/>
+              </a:lnSpc>
+              <a:spcAft>
+                <a:spcPts val="0"/>
+              </a:spcAft>
+            </a:pPr>
+            <a:r>
+              <a:rPr sz="1150" b="1" i="0">
+                <a:solidFill>
+                  <a:srgbClr val="162844"/>
+                </a:solidFill>
+                <a:latin typeface="Calibri"/>
+              </a:rPr>
+              <a:t>4%</a:t>
+            </a:r>
+          </a:p>
+        </p:txBody>
+      </p:sp>
+      <p:sp>
+        <p:nvSpPr>
+          <p:cNvPr id="31" name="TextBox 30"/>
+          <p:cNvSpPr txBox="1"/>
+          <p:nvPr/>
+        </p:nvSpPr>
+        <p:spPr>
+          <a:xfrm>
+            <a:off x="822960" y="4306824"/>
+            <a:ext cx="2423160" cy="365760"/>
           </a:xfrm>
           <a:prstGeom prst="rect">
             <a:avLst/>
@@ -11231,21 +11793,21 @@
                 </a:solidFill>
                 <a:latin typeface="Calibri"/>
               </a:rPr>
-              <a:t>RecurrenceService</a:t>
-            </a:r>
-          </a:p>
-        </p:txBody>
-      </p:sp>
-      <p:sp>
-        <p:nvSpPr>
-          <p:cNvPr id="19" name="Rectangle 18"/>
+              <a:t>ConflictDetector</a:t>
+            </a:r>
+          </a:p>
+        </p:txBody>
+      </p:sp>
+      <p:sp>
+        <p:nvSpPr>
+          <p:cNvPr id="32" name="Rectangle 31"/>
           <p:cNvSpPr/>
           <p:nvPr/>
         </p:nvSpPr>
         <p:spPr>
           <a:xfrm>
-            <a:off x="3291840" y="3438144"/>
-            <a:ext cx="7406640" cy="310896"/>
+            <a:off x="3383280" y="4197096"/>
+            <a:ext cx="7315200" cy="201168"/>
           </a:xfrm>
           <a:prstGeom prst="rect">
             <a:avLst/>
@@ -11282,14 +11844,14 @@
       </p:sp>
       <p:sp>
         <p:nvSpPr>
-          <p:cNvPr id="20" name="Rectangle 19"/>
+          <p:cNvPr id="33" name="Rectangle 32"/>
           <p:cNvSpPr/>
           <p:nvPr/>
         </p:nvSpPr>
         <p:spPr>
           <a:xfrm>
-            <a:off x="3291840" y="3438144"/>
-            <a:ext cx="5777179" cy="310896"/>
+            <a:off x="3383280" y="4197096"/>
+            <a:ext cx="7315200" cy="201168"/>
           </a:xfrm>
           <a:prstGeom prst="rect">
             <a:avLst/>
@@ -11326,14 +11888,14 @@
       </p:sp>
       <p:sp>
         <p:nvSpPr>
-          <p:cNvPr id="21" name="TextBox 20"/>
+          <p:cNvPr id="34" name="TextBox 33"/>
           <p:cNvSpPr txBox="1"/>
           <p:nvPr/>
         </p:nvSpPr>
         <p:spPr>
           <a:xfrm>
-            <a:off x="10789920" y="3456432"/>
-            <a:ext cx="640080" cy="320040"/>
+            <a:off x="10789920" y="4178808"/>
+            <a:ext cx="640080" cy="274320"/>
           </a:xfrm>
           <a:prstGeom prst="rect">
             <a:avLst/>
@@ -11355,27 +11917,157 @@
               </a:spcAft>
             </a:pPr>
             <a:r>
-              <a:rPr sz="1250" b="1" i="0">
+              <a:rPr sz="1150" b="1" i="0">
                 <a:solidFill>
                   <a:srgbClr val="162844"/>
                 </a:solidFill>
                 <a:latin typeface="Calibri"/>
               </a:rPr>
-              <a:t>78%</a:t>
-            </a:r>
-          </a:p>
-        </p:txBody>
-      </p:sp>
-      <p:sp>
-        <p:nvSpPr>
-          <p:cNvPr id="22" name="TextBox 21"/>
+              <a:t>100%</a:t>
+            </a:r>
+          </a:p>
+        </p:txBody>
+      </p:sp>
+      <p:sp>
+        <p:nvSpPr>
+          <p:cNvPr id="35" name="Rectangle 34"/>
+          <p:cNvSpPr/>
+          <p:nvPr/>
+        </p:nvSpPr>
+        <p:spPr>
+          <a:xfrm>
+            <a:off x="3383280" y="4453128"/>
+            <a:ext cx="7315200" cy="201168"/>
+          </a:xfrm>
+          <a:prstGeom prst="rect">
+            <a:avLst/>
+          </a:prstGeom>
+          <a:solidFill>
+            <a:srgbClr val="EAE6DA"/>
+          </a:solidFill>
+          <a:ln>
+            <a:noFill/>
+          </a:ln>
+          <a:effectLst/>
+        </p:spPr>
+        <p:style>
+          <a:lnRef idx="1">
+            <a:schemeClr val="accent1"/>
+          </a:lnRef>
+          <a:fillRef idx="3">
+            <a:schemeClr val="accent1"/>
+          </a:fillRef>
+          <a:effectRef idx="2">
+            <a:schemeClr val="accent1"/>
+          </a:effectRef>
+          <a:fontRef idx="minor">
+            <a:schemeClr val="lt1"/>
+          </a:fontRef>
+        </p:style>
+        <p:txBody>
+          <a:bodyPr rtlCol="0" anchor="ctr"/>
+          <a:lstStyle/>
+          <a:p>
+            <a:pPr algn="ctr"/>
+          </a:p>
+        </p:txBody>
+      </p:sp>
+      <p:sp>
+        <p:nvSpPr>
+          <p:cNvPr id="36" name="Rectangle 35"/>
+          <p:cNvSpPr/>
+          <p:nvPr/>
+        </p:nvSpPr>
+        <p:spPr>
+          <a:xfrm>
+            <a:off x="3383280" y="4453128"/>
+            <a:ext cx="5486400" cy="201168"/>
+          </a:xfrm>
+          <a:prstGeom prst="rect">
+            <a:avLst/>
+          </a:prstGeom>
+          <a:solidFill>
+            <a:srgbClr val="5C8C86"/>
+          </a:solidFill>
+          <a:ln>
+            <a:noFill/>
+          </a:ln>
+          <a:effectLst/>
+        </p:spPr>
+        <p:style>
+          <a:lnRef idx="1">
+            <a:schemeClr val="accent1"/>
+          </a:lnRef>
+          <a:fillRef idx="3">
+            <a:schemeClr val="accent1"/>
+          </a:fillRef>
+          <a:effectRef idx="2">
+            <a:schemeClr val="accent1"/>
+          </a:effectRef>
+          <a:fontRef idx="minor">
+            <a:schemeClr val="lt1"/>
+          </a:fontRef>
+        </p:style>
+        <p:txBody>
+          <a:bodyPr rtlCol="0" anchor="ctr"/>
+          <a:lstStyle/>
+          <a:p>
+            <a:pPr algn="ctr"/>
+          </a:p>
+        </p:txBody>
+      </p:sp>
+      <p:sp>
+        <p:nvSpPr>
+          <p:cNvPr id="37" name="TextBox 36"/>
           <p:cNvSpPr txBox="1"/>
           <p:nvPr/>
         </p:nvSpPr>
         <p:spPr>
           <a:xfrm>
-            <a:off x="822960" y="3941064"/>
-            <a:ext cx="2331720" cy="365760"/>
+            <a:off x="10789920" y="4434840"/>
+            <a:ext cx="640080" cy="274320"/>
+          </a:xfrm>
+          <a:prstGeom prst="rect">
+            <a:avLst/>
+          </a:prstGeom>
+          <a:noFill/>
+        </p:spPr>
+        <p:txBody>
+          <a:bodyPr wrap="square" anchor="t" lIns="0" rIns="0" tIns="0" bIns="0">
+            <a:spAutoFit/>
+          </a:bodyPr>
+          <a:lstStyle/>
+          <a:p>
+            <a:pPr algn="l">
+              <a:lnSpc>
+                <a:spcPct val="100000"/>
+              </a:lnSpc>
+              <a:spcAft>
+                <a:spcPts val="0"/>
+              </a:spcAft>
+            </a:pPr>
+            <a:r>
+              <a:rPr sz="1150" b="1" i="0">
+                <a:solidFill>
+                  <a:srgbClr val="162844"/>
+                </a:solidFill>
+                <a:latin typeface="Calibri"/>
+              </a:rPr>
+              <a:t>75%</a:t>
+            </a:r>
+          </a:p>
+        </p:txBody>
+      </p:sp>
+      <p:sp>
+        <p:nvSpPr>
+          <p:cNvPr id="38" name="TextBox 37"/>
+          <p:cNvSpPr txBox="1"/>
+          <p:nvPr/>
+        </p:nvSpPr>
+        <p:spPr>
+          <a:xfrm>
+            <a:off x="822960" y="4928616"/>
+            <a:ext cx="2423160" cy="365760"/>
           </a:xfrm>
           <a:prstGeom prst="rect">
             <a:avLst/>
@@ -11410,14 +12102,14 @@
       </p:sp>
       <p:sp>
         <p:nvSpPr>
-          <p:cNvPr id="23" name="Rectangle 22"/>
+          <p:cNvPr id="39" name="Rectangle 38"/>
           <p:cNvSpPr/>
           <p:nvPr/>
         </p:nvSpPr>
         <p:spPr>
           <a:xfrm>
-            <a:off x="3291840" y="3913632"/>
-            <a:ext cx="7406640" cy="310896"/>
+            <a:off x="3383280" y="4818888"/>
+            <a:ext cx="7315200" cy="201168"/>
           </a:xfrm>
           <a:prstGeom prst="rect">
             <a:avLst/>
@@ -11454,20 +12146,20 @@
       </p:sp>
       <p:sp>
         <p:nvSpPr>
-          <p:cNvPr id="24" name="Rectangle 23"/>
+          <p:cNvPr id="40" name="Rectangle 39"/>
           <p:cNvSpPr/>
           <p:nvPr/>
         </p:nvSpPr>
         <p:spPr>
           <a:xfrm>
-            <a:off x="3291840" y="3913632"/>
-            <a:ext cx="6517843" cy="310896"/>
-          </a:xfrm>
-          <a:prstGeom prst="rect">
-            <a:avLst/>
-          </a:prstGeom>
-          <a:solidFill>
-            <a:srgbClr val="839B74"/>
+            <a:off x="3383280" y="4818888"/>
+            <a:ext cx="6437376" cy="201168"/>
+          </a:xfrm>
+          <a:prstGeom prst="rect">
+            <a:avLst/>
+          </a:prstGeom>
+          <a:solidFill>
+            <a:srgbClr val="C79A52"/>
           </a:solidFill>
           <a:ln>
             <a:noFill/>
@@ -11498,14 +12190,14 @@
       </p:sp>
       <p:sp>
         <p:nvSpPr>
-          <p:cNvPr id="25" name="TextBox 24"/>
+          <p:cNvPr id="41" name="TextBox 40"/>
           <p:cNvSpPr txBox="1"/>
           <p:nvPr/>
         </p:nvSpPr>
         <p:spPr>
           <a:xfrm>
-            <a:off x="10789920" y="3931920"/>
-            <a:ext cx="640080" cy="320040"/>
+            <a:off x="10789920" y="4800600"/>
+            <a:ext cx="640080" cy="274320"/>
           </a:xfrm>
           <a:prstGeom prst="rect">
             <a:avLst/>
@@ -11527,7 +12219,7 @@
               </a:spcAft>
             </a:pPr>
             <a:r>
-              <a:rPr sz="1250" b="1" i="0">
+              <a:rPr sz="1150" b="1" i="0">
                 <a:solidFill>
                   <a:srgbClr val="162844"/>
                 </a:solidFill>
@@ -11540,14 +12232,144 @@
       </p:sp>
       <p:sp>
         <p:nvSpPr>
-          <p:cNvPr id="26" name="TextBox 25"/>
+          <p:cNvPr id="42" name="Rectangle 41"/>
+          <p:cNvSpPr/>
+          <p:nvPr/>
+        </p:nvSpPr>
+        <p:spPr>
+          <a:xfrm>
+            <a:off x="3383280" y="5074920"/>
+            <a:ext cx="7315200" cy="201168"/>
+          </a:xfrm>
+          <a:prstGeom prst="rect">
+            <a:avLst/>
+          </a:prstGeom>
+          <a:solidFill>
+            <a:srgbClr val="EAE6DA"/>
+          </a:solidFill>
+          <a:ln>
+            <a:noFill/>
+          </a:ln>
+          <a:effectLst/>
+        </p:spPr>
+        <p:style>
+          <a:lnRef idx="1">
+            <a:schemeClr val="accent1"/>
+          </a:lnRef>
+          <a:fillRef idx="3">
+            <a:schemeClr val="accent1"/>
+          </a:fillRef>
+          <a:effectRef idx="2">
+            <a:schemeClr val="accent1"/>
+          </a:effectRef>
+          <a:fontRef idx="minor">
+            <a:schemeClr val="lt1"/>
+          </a:fontRef>
+        </p:style>
+        <p:txBody>
+          <a:bodyPr rtlCol="0" anchor="ctr"/>
+          <a:lstStyle/>
+          <a:p>
+            <a:pPr algn="ctr"/>
+          </a:p>
+        </p:txBody>
+      </p:sp>
+      <p:sp>
+        <p:nvSpPr>
+          <p:cNvPr id="43" name="Rectangle 42"/>
+          <p:cNvSpPr/>
+          <p:nvPr/>
+        </p:nvSpPr>
+        <p:spPr>
+          <a:xfrm>
+            <a:off x="3383280" y="5074920"/>
+            <a:ext cx="6437376" cy="201168"/>
+          </a:xfrm>
+          <a:prstGeom prst="rect">
+            <a:avLst/>
+          </a:prstGeom>
+          <a:solidFill>
+            <a:srgbClr val="5C8C86"/>
+          </a:solidFill>
+          <a:ln>
+            <a:noFill/>
+          </a:ln>
+          <a:effectLst/>
+        </p:spPr>
+        <p:style>
+          <a:lnRef idx="1">
+            <a:schemeClr val="accent1"/>
+          </a:lnRef>
+          <a:fillRef idx="3">
+            <a:schemeClr val="accent1"/>
+          </a:fillRef>
+          <a:effectRef idx="2">
+            <a:schemeClr val="accent1"/>
+          </a:effectRef>
+          <a:fontRef idx="minor">
+            <a:schemeClr val="lt1"/>
+          </a:fontRef>
+        </p:style>
+        <p:txBody>
+          <a:bodyPr rtlCol="0" anchor="ctr"/>
+          <a:lstStyle/>
+          <a:p>
+            <a:pPr algn="ctr"/>
+          </a:p>
+        </p:txBody>
+      </p:sp>
+      <p:sp>
+        <p:nvSpPr>
+          <p:cNvPr id="44" name="TextBox 43"/>
           <p:cNvSpPr txBox="1"/>
           <p:nvPr/>
         </p:nvSpPr>
         <p:spPr>
           <a:xfrm>
-            <a:off x="822960" y="4416552"/>
-            <a:ext cx="2331720" cy="365760"/>
+            <a:off x="10789920" y="5056632"/>
+            <a:ext cx="640080" cy="274320"/>
+          </a:xfrm>
+          <a:prstGeom prst="rect">
+            <a:avLst/>
+          </a:prstGeom>
+          <a:noFill/>
+        </p:spPr>
+        <p:txBody>
+          <a:bodyPr wrap="square" anchor="t" lIns="0" rIns="0" tIns="0" bIns="0">
+            <a:spAutoFit/>
+          </a:bodyPr>
+          <a:lstStyle/>
+          <a:p>
+            <a:pPr algn="l">
+              <a:lnSpc>
+                <a:spcPct val="100000"/>
+              </a:lnSpc>
+              <a:spcAft>
+                <a:spcPts val="0"/>
+              </a:spcAft>
+            </a:pPr>
+            <a:r>
+              <a:rPr sz="1150" b="1" i="0">
+                <a:solidFill>
+                  <a:srgbClr val="162844"/>
+                </a:solidFill>
+                <a:latin typeface="Calibri"/>
+              </a:rPr>
+              <a:t>88%</a:t>
+            </a:r>
+          </a:p>
+        </p:txBody>
+      </p:sp>
+      <p:sp>
+        <p:nvSpPr>
+          <p:cNvPr id="45" name="TextBox 44"/>
+          <p:cNvSpPr txBox="1"/>
+          <p:nvPr/>
+        </p:nvSpPr>
+        <p:spPr>
+          <a:xfrm>
+            <a:off x="822960" y="5550408"/>
+            <a:ext cx="2423160" cy="365760"/>
           </a:xfrm>
           <a:prstGeom prst="rect">
             <a:avLst/>
@@ -11575,21 +12397,21 @@
                 </a:solidFill>
                 <a:latin typeface="Calibri"/>
               </a:rPr>
-              <a:t>HolidayService</a:t>
-            </a:r>
-          </a:p>
-        </p:txBody>
-      </p:sp>
-      <p:sp>
-        <p:nvSpPr>
-          <p:cNvPr id="27" name="Rectangle 26"/>
+              <a:t>RecurrenceRequest (DTO)</a:t>
+            </a:r>
+          </a:p>
+        </p:txBody>
+      </p:sp>
+      <p:sp>
+        <p:nvSpPr>
+          <p:cNvPr id="46" name="Rectangle 45"/>
           <p:cNvSpPr/>
           <p:nvPr/>
         </p:nvSpPr>
         <p:spPr>
           <a:xfrm>
-            <a:off x="3291840" y="4389120"/>
-            <a:ext cx="7406640" cy="310896"/>
+            <a:off x="3383280" y="5440680"/>
+            <a:ext cx="7315200" cy="201168"/>
           </a:xfrm>
           <a:prstGeom prst="rect">
             <a:avLst/>
@@ -11626,20 +12448,20 @@
       </p:sp>
       <p:sp>
         <p:nvSpPr>
-          <p:cNvPr id="28" name="Rectangle 27"/>
+          <p:cNvPr id="47" name="Rectangle 46"/>
           <p:cNvSpPr/>
           <p:nvPr/>
         </p:nvSpPr>
         <p:spPr>
           <a:xfrm>
-            <a:off x="3291840" y="4389120"/>
-            <a:ext cx="6888175" cy="310896"/>
-          </a:xfrm>
-          <a:prstGeom prst="rect">
-            <a:avLst/>
-          </a:prstGeom>
-          <a:solidFill>
-            <a:srgbClr val="839B74"/>
+            <a:off x="3383280" y="5440680"/>
+            <a:ext cx="73152" cy="201168"/>
+          </a:xfrm>
+          <a:prstGeom prst="rect">
+            <a:avLst/>
+          </a:prstGeom>
+          <a:solidFill>
+            <a:srgbClr val="C79A52"/>
           </a:solidFill>
           <a:ln>
             <a:noFill/>
@@ -11670,14 +12492,14 @@
       </p:sp>
       <p:sp>
         <p:nvSpPr>
-          <p:cNvPr id="29" name="TextBox 28"/>
+          <p:cNvPr id="48" name="TextBox 47"/>
           <p:cNvSpPr txBox="1"/>
           <p:nvPr/>
         </p:nvSpPr>
         <p:spPr>
           <a:xfrm>
-            <a:off x="10789920" y="4407408"/>
-            <a:ext cx="640080" cy="320040"/>
+            <a:off x="10789920" y="5422392"/>
+            <a:ext cx="640080" cy="274320"/>
           </a:xfrm>
           <a:prstGeom prst="rect">
             <a:avLst/>
@@ -11699,27 +12521,199 @@
               </a:spcAft>
             </a:pPr>
             <a:r>
-              <a:rPr sz="1250" b="1" i="0">
+              <a:rPr sz="1150" b="1" i="0">
                 <a:solidFill>
                   <a:srgbClr val="162844"/>
                 </a:solidFill>
                 <a:latin typeface="Calibri"/>
               </a:rPr>
-              <a:t>93%</a:t>
-            </a:r>
-          </a:p>
-        </p:txBody>
-      </p:sp>
-      <p:sp>
-        <p:nvSpPr>
-          <p:cNvPr id="30" name="TextBox 29"/>
+              <a:t>0%</a:t>
+            </a:r>
+          </a:p>
+        </p:txBody>
+      </p:sp>
+      <p:sp>
+        <p:nvSpPr>
+          <p:cNvPr id="49" name="Rectangle 48"/>
+          <p:cNvSpPr/>
+          <p:nvPr/>
+        </p:nvSpPr>
+        <p:spPr>
+          <a:xfrm>
+            <a:off x="3383280" y="5696712"/>
+            <a:ext cx="7315200" cy="201168"/>
+          </a:xfrm>
+          <a:prstGeom prst="rect">
+            <a:avLst/>
+          </a:prstGeom>
+          <a:solidFill>
+            <a:srgbClr val="EAE6DA"/>
+          </a:solidFill>
+          <a:ln>
+            <a:noFill/>
+          </a:ln>
+          <a:effectLst/>
+        </p:spPr>
+        <p:style>
+          <a:lnRef idx="1">
+            <a:schemeClr val="accent1"/>
+          </a:lnRef>
+          <a:fillRef idx="3">
+            <a:schemeClr val="accent1"/>
+          </a:fillRef>
+          <a:effectRef idx="2">
+            <a:schemeClr val="accent1"/>
+          </a:effectRef>
+          <a:fontRef idx="minor">
+            <a:schemeClr val="lt1"/>
+          </a:fontRef>
+        </p:style>
+        <p:txBody>
+          <a:bodyPr rtlCol="0" anchor="ctr"/>
+          <a:lstStyle/>
+          <a:p>
+            <a:pPr algn="ctr"/>
+          </a:p>
+        </p:txBody>
+      </p:sp>
+      <p:sp>
+        <p:nvSpPr>
+          <p:cNvPr id="50" name="Rectangle 49"/>
+          <p:cNvSpPr/>
+          <p:nvPr/>
+        </p:nvSpPr>
+        <p:spPr>
+          <a:xfrm>
+            <a:off x="3383280" y="5696712"/>
+            <a:ext cx="73152" cy="201168"/>
+          </a:xfrm>
+          <a:prstGeom prst="rect">
+            <a:avLst/>
+          </a:prstGeom>
+          <a:solidFill>
+            <a:srgbClr val="5C8C86"/>
+          </a:solidFill>
+          <a:ln>
+            <a:noFill/>
+          </a:ln>
+          <a:effectLst/>
+        </p:spPr>
+        <p:style>
+          <a:lnRef idx="1">
+            <a:schemeClr val="accent1"/>
+          </a:lnRef>
+          <a:fillRef idx="3">
+            <a:schemeClr val="accent1"/>
+          </a:fillRef>
+          <a:effectRef idx="2">
+            <a:schemeClr val="accent1"/>
+          </a:effectRef>
+          <a:fontRef idx="minor">
+            <a:schemeClr val="lt1"/>
+          </a:fontRef>
+        </p:style>
+        <p:txBody>
+          <a:bodyPr rtlCol="0" anchor="ctr"/>
+          <a:lstStyle/>
+          <a:p>
+            <a:pPr algn="ctr"/>
+          </a:p>
+        </p:txBody>
+      </p:sp>
+      <p:sp>
+        <p:nvSpPr>
+          <p:cNvPr id="51" name="TextBox 50"/>
           <p:cNvSpPr txBox="1"/>
           <p:nvPr/>
         </p:nvSpPr>
         <p:spPr>
           <a:xfrm>
-            <a:off x="822960" y="4892040"/>
-            <a:ext cx="2331720" cy="365760"/>
+            <a:off x="10789920" y="5678424"/>
+            <a:ext cx="640080" cy="274320"/>
+          </a:xfrm>
+          <a:prstGeom prst="rect">
+            <a:avLst/>
+          </a:prstGeom>
+          <a:noFill/>
+        </p:spPr>
+        <p:txBody>
+          <a:bodyPr wrap="square" anchor="t" lIns="0" rIns="0" tIns="0" bIns="0">
+            <a:spAutoFit/>
+          </a:bodyPr>
+          <a:lstStyle/>
+          <a:p>
+            <a:pPr algn="l">
+              <a:lnSpc>
+                <a:spcPct val="100000"/>
+              </a:lnSpc>
+              <a:spcAft>
+                <a:spcPts val="0"/>
+              </a:spcAft>
+            </a:pPr>
+            <a:r>
+              <a:rPr sz="1150" b="1" i="0">
+                <a:solidFill>
+                  <a:srgbClr val="162844"/>
+                </a:solidFill>
+                <a:latin typeface="Calibri"/>
+              </a:rPr>
+              <a:t>0%</a:t>
+            </a:r>
+          </a:p>
+        </p:txBody>
+      </p:sp>
+      <p:sp>
+        <p:nvSpPr>
+          <p:cNvPr id="52" name="TextBox 51"/>
+          <p:cNvSpPr txBox="1"/>
+          <p:nvPr/>
+        </p:nvSpPr>
+        <p:spPr>
+          <a:xfrm>
+            <a:off x="822960" y="6053328"/>
+            <a:ext cx="10058400" cy="320040"/>
+          </a:xfrm>
+          <a:prstGeom prst="rect">
+            <a:avLst/>
+          </a:prstGeom>
+          <a:noFill/>
+        </p:spPr>
+        <p:txBody>
+          <a:bodyPr wrap="square" anchor="t" lIns="0" rIns="0" tIns="0" bIns="0">
+            <a:spAutoFit/>
+          </a:bodyPr>
+          <a:lstStyle/>
+          <a:p>
+            <a:pPr algn="l">
+              <a:lnSpc>
+                <a:spcPct val="100000"/>
+              </a:lnSpc>
+              <a:spcAft>
+                <a:spcPts val="0"/>
+              </a:spcAft>
+            </a:pPr>
+            <a:r>
+              <a:rPr sz="1200" b="0" i="1">
+                <a:solidFill>
+                  <a:srgbClr val="8B93A1"/>
+                </a:solidFill>
+                <a:latin typeface="Calibri"/>
+              </a:rPr>
+              <a:t>JUnit couvre la logique métier ; Cucumber couvre la couche REST — presque aucun recouvrement.</a:t>
+            </a:r>
+          </a:p>
+        </p:txBody>
+      </p:sp>
+      <p:sp>
+        <p:nvSpPr>
+          <p:cNvPr id="53" name="TextBox 52"/>
+          <p:cNvSpPr txBox="1"/>
+          <p:nvPr/>
+        </p:nvSpPr>
+        <p:spPr>
+          <a:xfrm>
+            <a:off x="11155680" y="6473952"/>
+            <a:ext cx="822960" cy="274320"/>
           </a:xfrm>
           <a:prstGeom prst="rect">
             <a:avLst/>
@@ -11741,178 +12735,6 @@
               </a:spcAft>
             </a:pPr>
             <a:r>
-              <a:rPr sz="1250" b="0" i="0">
-                <a:solidFill>
-                  <a:srgbClr val="162844"/>
-                </a:solidFill>
-                <a:latin typeface="Calibri"/>
-              </a:rPr>
-              <a:t>QuoteOfTheDayService</a:t>
-            </a:r>
-          </a:p>
-        </p:txBody>
-      </p:sp>
-      <p:sp>
-        <p:nvSpPr>
-          <p:cNvPr id="31" name="Rectangle 30"/>
-          <p:cNvSpPr/>
-          <p:nvPr/>
-        </p:nvSpPr>
-        <p:spPr>
-          <a:xfrm>
-            <a:off x="3291840" y="4864608"/>
-            <a:ext cx="7406640" cy="310896"/>
-          </a:xfrm>
-          <a:prstGeom prst="rect">
-            <a:avLst/>
-          </a:prstGeom>
-          <a:solidFill>
-            <a:srgbClr val="EAE6DA"/>
-          </a:solidFill>
-          <a:ln>
-            <a:noFill/>
-          </a:ln>
-          <a:effectLst/>
-        </p:spPr>
-        <p:style>
-          <a:lnRef idx="1">
-            <a:schemeClr val="accent1"/>
-          </a:lnRef>
-          <a:fillRef idx="3">
-            <a:schemeClr val="accent1"/>
-          </a:fillRef>
-          <a:effectRef idx="2">
-            <a:schemeClr val="accent1"/>
-          </a:effectRef>
-          <a:fontRef idx="minor">
-            <a:schemeClr val="lt1"/>
-          </a:fontRef>
-        </p:style>
-        <p:txBody>
-          <a:bodyPr rtlCol="0" anchor="ctr"/>
-          <a:lstStyle/>
-          <a:p>
-            <a:pPr algn="ctr"/>
-          </a:p>
-        </p:txBody>
-      </p:sp>
-      <p:sp>
-        <p:nvSpPr>
-          <p:cNvPr id="32" name="Rectangle 31"/>
-          <p:cNvSpPr/>
-          <p:nvPr/>
-        </p:nvSpPr>
-        <p:spPr>
-          <a:xfrm>
-            <a:off x="3291840" y="4864608"/>
-            <a:ext cx="7406640" cy="310896"/>
-          </a:xfrm>
-          <a:prstGeom prst="rect">
-            <a:avLst/>
-          </a:prstGeom>
-          <a:solidFill>
-            <a:srgbClr val="839B74"/>
-          </a:solidFill>
-          <a:ln>
-            <a:noFill/>
-          </a:ln>
-          <a:effectLst/>
-        </p:spPr>
-        <p:style>
-          <a:lnRef idx="1">
-            <a:schemeClr val="accent1"/>
-          </a:lnRef>
-          <a:fillRef idx="3">
-            <a:schemeClr val="accent1"/>
-          </a:fillRef>
-          <a:effectRef idx="2">
-            <a:schemeClr val="accent1"/>
-          </a:effectRef>
-          <a:fontRef idx="minor">
-            <a:schemeClr val="lt1"/>
-          </a:fontRef>
-        </p:style>
-        <p:txBody>
-          <a:bodyPr rtlCol="0" anchor="ctr"/>
-          <a:lstStyle/>
-          <a:p>
-            <a:pPr algn="ctr"/>
-          </a:p>
-        </p:txBody>
-      </p:sp>
-      <p:sp>
-        <p:nvSpPr>
-          <p:cNvPr id="33" name="TextBox 32"/>
-          <p:cNvSpPr txBox="1"/>
-          <p:nvPr/>
-        </p:nvSpPr>
-        <p:spPr>
-          <a:xfrm>
-            <a:off x="10789920" y="4882896"/>
-            <a:ext cx="640080" cy="320040"/>
-          </a:xfrm>
-          <a:prstGeom prst="rect">
-            <a:avLst/>
-          </a:prstGeom>
-          <a:noFill/>
-        </p:spPr>
-        <p:txBody>
-          <a:bodyPr wrap="square" anchor="t" lIns="0" rIns="0" tIns="0" bIns="0">
-            <a:spAutoFit/>
-          </a:bodyPr>
-          <a:lstStyle/>
-          <a:p>
-            <a:pPr algn="l">
-              <a:lnSpc>
-                <a:spcPct val="100000"/>
-              </a:lnSpc>
-              <a:spcAft>
-                <a:spcPts val="0"/>
-              </a:spcAft>
-            </a:pPr>
-            <a:r>
-              <a:rPr sz="1250" b="1" i="0">
-                <a:solidFill>
-                  <a:srgbClr val="162844"/>
-                </a:solidFill>
-                <a:latin typeface="Calibri"/>
-              </a:rPr>
-              <a:t>100%</a:t>
-            </a:r>
-          </a:p>
-        </p:txBody>
-      </p:sp>
-      <p:sp>
-        <p:nvSpPr>
-          <p:cNvPr id="34" name="TextBox 33"/>
-          <p:cNvSpPr txBox="1"/>
-          <p:nvPr/>
-        </p:nvSpPr>
-        <p:spPr>
-          <a:xfrm>
-            <a:off x="11155680" y="6473952"/>
-            <a:ext cx="822960" cy="274320"/>
-          </a:xfrm>
-          <a:prstGeom prst="rect">
-            <a:avLst/>
-          </a:prstGeom>
-          <a:noFill/>
-        </p:spPr>
-        <p:txBody>
-          <a:bodyPr wrap="square" anchor="t" lIns="0" rIns="0" tIns="0" bIns="0">
-            <a:spAutoFit/>
-          </a:bodyPr>
-          <a:lstStyle/>
-          <a:p>
-            <a:pPr algn="r">
-              <a:lnSpc>
-                <a:spcPct val="100000"/>
-              </a:lnSpc>
-              <a:spcAft>
-                <a:spcPts val="0"/>
-              </a:spcAft>
-            </a:pPr>
-            <a:r>
               <a:rPr sz="1000" b="0" i="0">
                 <a:solidFill>
                   <a:srgbClr val="8B93A1"/>
@@ -11926,7 +12748,7 @@
       </p:sp>
       <p:sp>
         <p:nvSpPr>
-          <p:cNvPr id="35" name="TextBox 34"/>
+          <p:cNvPr id="54" name="TextBox 53"/>
           <p:cNvSpPr txBox="1"/>
           <p:nvPr/>
         </p:nvSpPr>
@@ -12285,7 +13107,7 @@
                 </a:solidFill>
                 <a:latin typeface="Calibri"/>
               </a:rPr>
-              <a:t>Build + JUnit + Cucumber + rapport Jacoco généré automatiquement.</a:t>
+              <a:t>Build + JUnit + Cucumber + 3 rapports Jacoco générés automatiquement.</a:t>
             </a:r>
           </a:p>
         </p:txBody>
@@ -12455,7 +13277,7 @@
                 </a:solidFill>
                 <a:latin typeface="Calibri"/>
               </a:rPr>
-              <a:t>Le récap coloré, classe par classe, directement dans le terminal.</a:t>
+              <a:t>Le récap coloré JUnit / Cucumber / global, côte à côte, dans le terminal.</a:t>
             </a:r>
           </a:p>
         </p:txBody>
@@ -12625,7 +13447,7 @@
                 </a:solidFill>
                 <a:latin typeface="Calibri"/>
               </a:rPr>
-              <a:t>Le détail ligne par ligne, pour creuser une classe en particulier.</a:t>
+              <a:t>Le détail ligne par ligne — et les variantes -junit / -cucumber pour comparer.</a:t>
             </a:r>
           </a:p>
         </p:txBody>

</xml_diff>

<commit_message>
Integrer SonarQube pour visualiser la couverture Jacoco
Ajoute sonar-maven-plugin (invocation manuelle, non lie au lifecycle) qui
importe directement les rapports Jacoco XML JUnit + Cucumber et recalcule
leur union. sonarqube/docker-compose.yml permet de lancer une instance
Community locale pour la demo, sans compte SonarCloud. Integration validee
de bout en bout (77.7% de couverture globale remontee dans Sonar, coherent
avec le rapport jacoco-report fusionne).

Documentation (CLAUDE.md, DESCRIPTION.md, PROMPT.md) et presentation mises
a jour avec la procedure de validation et une nouvelle slide bonus.

Co-Authored-By: Claude Sonnet 5 <noreply@anthropic.com>
Claude-Session: https://claude.ai/code/session_01UJ8K2KSjB3mCiTjCx3LvFL
</commit_message>
<xml_diff>
--- a/presentation/couverture-code-conference.pptx
+++ b/presentation/couverture-code-conference.pptx
@@ -15,6 +15,7 @@
     <p:sldId id="263" r:id="rId14"/>
     <p:sldId id="264" r:id="rId15"/>
     <p:sldId id="265" r:id="rId16"/>
+    <p:sldId id="266" r:id="rId17"/>
   </p:sldIdLst>
   <p:sldSz cx="12191695" cy="6858000" type="screen4x3"/>
   <p:notesSz cx="6858000" cy="9144000"/>
@@ -4684,6 +4685,578 @@
       <p:grpSpPr/>
       <p:sp>
         <p:nvSpPr>
+          <p:cNvPr id="2" name="TextBox 1"/>
+          <p:cNvSpPr txBox="1"/>
+          <p:nvPr/>
+        </p:nvSpPr>
+        <p:spPr>
+          <a:xfrm>
+            <a:off x="822960" y="548640"/>
+            <a:ext cx="7315200" cy="365760"/>
+          </a:xfrm>
+          <a:prstGeom prst="rect">
+            <a:avLst/>
+          </a:prstGeom>
+          <a:noFill/>
+        </p:spPr>
+        <p:txBody>
+          <a:bodyPr wrap="square" anchor="t" lIns="0" rIns="0" tIns="0" bIns="0">
+            <a:spAutoFit/>
+          </a:bodyPr>
+          <a:lstStyle/>
+          <a:p>
+            <a:pPr algn="l">
+              <a:lnSpc>
+                <a:spcPct val="100000"/>
+              </a:lnSpc>
+              <a:spcAft>
+                <a:spcPts val="0"/>
+              </a:spcAft>
+            </a:pPr>
+            <a:r>
+              <a:rPr sz="1300" b="1" i="0">
+                <a:solidFill>
+                  <a:srgbClr val="C79A52"/>
+                </a:solidFill>
+                <a:latin typeface="Calibri"/>
+              </a:rPr>
+              <a:t>À RETENIR</a:t>
+            </a:r>
+          </a:p>
+        </p:txBody>
+      </p:sp>
+      <p:sp>
+        <p:nvSpPr>
+          <p:cNvPr id="3" name="TextBox 2"/>
+          <p:cNvSpPr txBox="1"/>
+          <p:nvPr/>
+        </p:nvSpPr>
+        <p:spPr>
+          <a:xfrm>
+            <a:off x="822960" y="868680"/>
+            <a:ext cx="10058400" cy="822960"/>
+          </a:xfrm>
+          <a:prstGeom prst="rect">
+            <a:avLst/>
+          </a:prstGeom>
+          <a:noFill/>
+        </p:spPr>
+        <p:txBody>
+          <a:bodyPr wrap="square" anchor="t" lIns="0" rIns="0" tIns="0" bIns="0">
+            <a:spAutoFit/>
+          </a:bodyPr>
+          <a:lstStyle/>
+          <a:p>
+            <a:pPr algn="l">
+              <a:lnSpc>
+                <a:spcPct val="100000"/>
+              </a:lnSpc>
+              <a:spcAft>
+                <a:spcPts val="0"/>
+              </a:spcAft>
+            </a:pPr>
+            <a:r>
+              <a:rPr sz="3200" b="1" i="0">
+                <a:solidFill>
+                  <a:srgbClr val="EFECE3"/>
+                </a:solidFill>
+                <a:latin typeface="Calibri"/>
+              </a:rPr>
+              <a:t>Ce qu'il faut retenir</a:t>
+            </a:r>
+          </a:p>
+        </p:txBody>
+      </p:sp>
+      <p:sp>
+        <p:nvSpPr>
+          <p:cNvPr id="4" name="TextBox 3"/>
+          <p:cNvSpPr txBox="1"/>
+          <p:nvPr/>
+        </p:nvSpPr>
+        <p:spPr>
+          <a:xfrm>
+            <a:off x="822960" y="2103120"/>
+            <a:ext cx="1097280" cy="1097280"/>
+          </a:xfrm>
+          <a:prstGeom prst="rect">
+            <a:avLst/>
+          </a:prstGeom>
+          <a:noFill/>
+        </p:spPr>
+        <p:txBody>
+          <a:bodyPr wrap="square" anchor="t" lIns="0" rIns="0" tIns="0" bIns="0">
+            <a:spAutoFit/>
+          </a:bodyPr>
+          <a:lstStyle/>
+          <a:p>
+            <a:pPr algn="l">
+              <a:lnSpc>
+                <a:spcPct val="100000"/>
+              </a:lnSpc>
+              <a:spcAft>
+                <a:spcPts val="0"/>
+              </a:spcAft>
+            </a:pPr>
+            <a:r>
+              <a:rPr sz="3400" b="1" i="0">
+                <a:solidFill>
+                  <a:srgbClr val="C79A52"/>
+                </a:solidFill>
+                <a:latin typeface="Calibri"/>
+              </a:rPr>
+              <a:t>01</a:t>
+            </a:r>
+          </a:p>
+        </p:txBody>
+      </p:sp>
+      <p:sp>
+        <p:nvSpPr>
+          <p:cNvPr id="5" name="TextBox 4"/>
+          <p:cNvSpPr txBox="1"/>
+          <p:nvPr/>
+        </p:nvSpPr>
+        <p:spPr>
+          <a:xfrm>
+            <a:off x="2011680" y="2148840"/>
+            <a:ext cx="8961120" cy="502920"/>
+          </a:xfrm>
+          <a:prstGeom prst="rect">
+            <a:avLst/>
+          </a:prstGeom>
+          <a:noFill/>
+        </p:spPr>
+        <p:txBody>
+          <a:bodyPr wrap="square" anchor="t" lIns="0" rIns="0" tIns="0" bIns="0">
+            <a:spAutoFit/>
+          </a:bodyPr>
+          <a:lstStyle/>
+          <a:p>
+            <a:pPr algn="l">
+              <a:lnSpc>
+                <a:spcPct val="100000"/>
+              </a:lnSpc>
+              <a:spcAft>
+                <a:spcPts val="0"/>
+              </a:spcAft>
+            </a:pPr>
+            <a:r>
+              <a:rPr sz="1800" b="1" i="0">
+                <a:solidFill>
+                  <a:srgbClr val="EFECE3"/>
+                </a:solidFill>
+                <a:latin typeface="Calibri"/>
+              </a:rPr>
+              <a:t>Un test vert ne dit pas ce qu'il a vérifié.</a:t>
+            </a:r>
+          </a:p>
+        </p:txBody>
+      </p:sp>
+      <p:sp>
+        <p:nvSpPr>
+          <p:cNvPr id="6" name="TextBox 5"/>
+          <p:cNvSpPr txBox="1"/>
+          <p:nvPr/>
+        </p:nvSpPr>
+        <p:spPr>
+          <a:xfrm>
+            <a:off x="2011680" y="2633472"/>
+            <a:ext cx="8961120" cy="457200"/>
+          </a:xfrm>
+          <a:prstGeom prst="rect">
+            <a:avLst/>
+          </a:prstGeom>
+          <a:noFill/>
+        </p:spPr>
+        <p:txBody>
+          <a:bodyPr wrap="square" anchor="t" lIns="0" rIns="0" tIns="0" bIns="0">
+            <a:spAutoFit/>
+          </a:bodyPr>
+          <a:lstStyle/>
+          <a:p>
+            <a:pPr algn="l">
+              <a:lnSpc>
+                <a:spcPct val="100000"/>
+              </a:lnSpc>
+              <a:spcAft>
+                <a:spcPts val="0"/>
+              </a:spcAft>
+            </a:pPr>
+            <a:r>
+              <a:rPr sz="1400" b="0" i="0">
+                <a:solidFill>
+                  <a:srgbClr val="8B93A1"/>
+                </a:solidFill>
+                <a:latin typeface="Calibri"/>
+              </a:rPr>
+              <a:t>La couverture, si.</a:t>
+            </a:r>
+          </a:p>
+        </p:txBody>
+      </p:sp>
+      <p:sp>
+        <p:nvSpPr>
+          <p:cNvPr id="7" name="TextBox 6"/>
+          <p:cNvSpPr txBox="1"/>
+          <p:nvPr/>
+        </p:nvSpPr>
+        <p:spPr>
+          <a:xfrm>
+            <a:off x="822960" y="3429000"/>
+            <a:ext cx="1097280" cy="1097280"/>
+          </a:xfrm>
+          <a:prstGeom prst="rect">
+            <a:avLst/>
+          </a:prstGeom>
+          <a:noFill/>
+        </p:spPr>
+        <p:txBody>
+          <a:bodyPr wrap="square" anchor="t" lIns="0" rIns="0" tIns="0" bIns="0">
+            <a:spAutoFit/>
+          </a:bodyPr>
+          <a:lstStyle/>
+          <a:p>
+            <a:pPr algn="l">
+              <a:lnSpc>
+                <a:spcPct val="100000"/>
+              </a:lnSpc>
+              <a:spcAft>
+                <a:spcPts val="0"/>
+              </a:spcAft>
+            </a:pPr>
+            <a:r>
+              <a:rPr sz="3400" b="1" i="0">
+                <a:solidFill>
+                  <a:srgbClr val="C79A52"/>
+                </a:solidFill>
+                <a:latin typeface="Calibri"/>
+              </a:rPr>
+              <a:t>02</a:t>
+            </a:r>
+          </a:p>
+        </p:txBody>
+      </p:sp>
+      <p:sp>
+        <p:nvSpPr>
+          <p:cNvPr id="8" name="TextBox 7"/>
+          <p:cNvSpPr txBox="1"/>
+          <p:nvPr/>
+        </p:nvSpPr>
+        <p:spPr>
+          <a:xfrm>
+            <a:off x="2011680" y="3474720"/>
+            <a:ext cx="8961120" cy="502920"/>
+          </a:xfrm>
+          <a:prstGeom prst="rect">
+            <a:avLst/>
+          </a:prstGeom>
+          <a:noFill/>
+        </p:spPr>
+        <p:txBody>
+          <a:bodyPr wrap="square" anchor="t" lIns="0" rIns="0" tIns="0" bIns="0">
+            <a:spAutoFit/>
+          </a:bodyPr>
+          <a:lstStyle/>
+          <a:p>
+            <a:pPr algn="l">
+              <a:lnSpc>
+                <a:spcPct val="100000"/>
+              </a:lnSpc>
+              <a:spcAft>
+                <a:spcPts val="0"/>
+              </a:spcAft>
+            </a:pPr>
+            <a:r>
+              <a:rPr sz="1800" b="1" i="0">
+                <a:solidFill>
+                  <a:srgbClr val="EFECE3"/>
+                </a:solidFill>
+                <a:latin typeface="Calibri"/>
+              </a:rPr>
+              <a:t>JUnit et Cucumber répondent à deux questions différentes.</a:t>
+            </a:r>
+          </a:p>
+        </p:txBody>
+      </p:sp>
+      <p:sp>
+        <p:nvSpPr>
+          <p:cNvPr id="9" name="TextBox 8"/>
+          <p:cNvSpPr txBox="1"/>
+          <p:nvPr/>
+        </p:nvSpPr>
+        <p:spPr>
+          <a:xfrm>
+            <a:off x="2011680" y="3959352"/>
+            <a:ext cx="8961120" cy="457200"/>
+          </a:xfrm>
+          <a:prstGeom prst="rect">
+            <a:avLst/>
+          </a:prstGeom>
+          <a:noFill/>
+        </p:spPr>
+        <p:txBody>
+          <a:bodyPr wrap="square" anchor="t" lIns="0" rIns="0" tIns="0" bIns="0">
+            <a:spAutoFit/>
+          </a:bodyPr>
+          <a:lstStyle/>
+          <a:p>
+            <a:pPr algn="l">
+              <a:lnSpc>
+                <a:spcPct val="100000"/>
+              </a:lnSpc>
+              <a:spcAft>
+                <a:spcPts val="0"/>
+              </a:spcAft>
+            </a:pPr>
+            <a:r>
+              <a:rPr sz="1400" b="0" i="0">
+                <a:solidFill>
+                  <a:srgbClr val="8B93A1"/>
+                </a:solidFill>
+                <a:latin typeface="Calibri"/>
+              </a:rPr>
+              <a:t>« Ça marche ? » contre « c'est le bon comportement ? »</a:t>
+            </a:r>
+          </a:p>
+        </p:txBody>
+      </p:sp>
+      <p:sp>
+        <p:nvSpPr>
+          <p:cNvPr id="10" name="TextBox 9"/>
+          <p:cNvSpPr txBox="1"/>
+          <p:nvPr/>
+        </p:nvSpPr>
+        <p:spPr>
+          <a:xfrm>
+            <a:off x="822960" y="4754880"/>
+            <a:ext cx="1097280" cy="1097280"/>
+          </a:xfrm>
+          <a:prstGeom prst="rect">
+            <a:avLst/>
+          </a:prstGeom>
+          <a:noFill/>
+        </p:spPr>
+        <p:txBody>
+          <a:bodyPr wrap="square" anchor="t" lIns="0" rIns="0" tIns="0" bIns="0">
+            <a:spAutoFit/>
+          </a:bodyPr>
+          <a:lstStyle/>
+          <a:p>
+            <a:pPr algn="l">
+              <a:lnSpc>
+                <a:spcPct val="100000"/>
+              </a:lnSpc>
+              <a:spcAft>
+                <a:spcPts val="0"/>
+              </a:spcAft>
+            </a:pPr>
+            <a:r>
+              <a:rPr sz="3400" b="1" i="0">
+                <a:solidFill>
+                  <a:srgbClr val="C79A52"/>
+                </a:solidFill>
+                <a:latin typeface="Calibri"/>
+              </a:rPr>
+              <a:t>03</a:t>
+            </a:r>
+          </a:p>
+        </p:txBody>
+      </p:sp>
+      <p:sp>
+        <p:nvSpPr>
+          <p:cNvPr id="11" name="TextBox 10"/>
+          <p:cNvSpPr txBox="1"/>
+          <p:nvPr/>
+        </p:nvSpPr>
+        <p:spPr>
+          <a:xfrm>
+            <a:off x="2011680" y="4800600"/>
+            <a:ext cx="8961120" cy="502920"/>
+          </a:xfrm>
+          <a:prstGeom prst="rect">
+            <a:avLst/>
+          </a:prstGeom>
+          <a:noFill/>
+        </p:spPr>
+        <p:txBody>
+          <a:bodyPr wrap="square" anchor="t" lIns="0" rIns="0" tIns="0" bIns="0">
+            <a:spAutoFit/>
+          </a:bodyPr>
+          <a:lstStyle/>
+          <a:p>
+            <a:pPr algn="l">
+              <a:lnSpc>
+                <a:spcPct val="100000"/>
+              </a:lnSpc>
+              <a:spcAft>
+                <a:spcPts val="0"/>
+              </a:spcAft>
+            </a:pPr>
+            <a:r>
+              <a:rPr sz="1800" b="1" i="0">
+                <a:solidFill>
+                  <a:srgbClr val="EFECE3"/>
+                </a:solidFill>
+                <a:latin typeface="Calibri"/>
+              </a:rPr>
+              <a:t>Le rapport de couverture n'est pas un objectif.</a:t>
+            </a:r>
+          </a:p>
+        </p:txBody>
+      </p:sp>
+      <p:sp>
+        <p:nvSpPr>
+          <p:cNvPr id="12" name="TextBox 11"/>
+          <p:cNvSpPr txBox="1"/>
+          <p:nvPr/>
+        </p:nvSpPr>
+        <p:spPr>
+          <a:xfrm>
+            <a:off x="2011680" y="5285232"/>
+            <a:ext cx="8961120" cy="457200"/>
+          </a:xfrm>
+          <a:prstGeom prst="rect">
+            <a:avLst/>
+          </a:prstGeom>
+          <a:noFill/>
+        </p:spPr>
+        <p:txBody>
+          <a:bodyPr wrap="square" anchor="t" lIns="0" rIns="0" tIns="0" bIns="0">
+            <a:spAutoFit/>
+          </a:bodyPr>
+          <a:lstStyle/>
+          <a:p>
+            <a:pPr algn="l">
+              <a:lnSpc>
+                <a:spcPct val="100000"/>
+              </a:lnSpc>
+              <a:spcAft>
+                <a:spcPts val="0"/>
+              </a:spcAft>
+            </a:pPr>
+            <a:r>
+              <a:rPr sz="1400" b="0" i="0">
+                <a:solidFill>
+                  <a:srgbClr val="8B93A1"/>
+                </a:solidFill>
+                <a:latin typeface="Calibri"/>
+              </a:rPr>
+              <a:t>C'est un radar : il montre où regarder en premier.</a:t>
+            </a:r>
+          </a:p>
+        </p:txBody>
+      </p:sp>
+      <p:sp>
+        <p:nvSpPr>
+          <p:cNvPr id="13" name="TextBox 12"/>
+          <p:cNvSpPr txBox="1"/>
+          <p:nvPr/>
+        </p:nvSpPr>
+        <p:spPr>
+          <a:xfrm>
+            <a:off x="11155680" y="6473952"/>
+            <a:ext cx="822960" cy="274320"/>
+          </a:xfrm>
+          <a:prstGeom prst="rect">
+            <a:avLst/>
+          </a:prstGeom>
+          <a:noFill/>
+        </p:spPr>
+        <p:txBody>
+          <a:bodyPr wrap="square" anchor="t" lIns="0" rIns="0" tIns="0" bIns="0">
+            <a:spAutoFit/>
+          </a:bodyPr>
+          <a:lstStyle/>
+          <a:p>
+            <a:pPr algn="r">
+              <a:lnSpc>
+                <a:spcPct val="100000"/>
+              </a:lnSpc>
+              <a:spcAft>
+                <a:spcPts val="0"/>
+              </a:spcAft>
+            </a:pPr>
+            <a:r>
+              <a:rPr sz="1000" b="0" i="0">
+                <a:solidFill>
+                  <a:srgbClr val="6E7A8E"/>
+                </a:solidFill>
+                <a:latin typeface="Calibri"/>
+              </a:rPr>
+              <a:t>10 / 11</a:t>
+            </a:r>
+          </a:p>
+        </p:txBody>
+      </p:sp>
+      <p:sp>
+        <p:nvSpPr>
+          <p:cNvPr id="14" name="TextBox 13"/>
+          <p:cNvSpPr txBox="1"/>
+          <p:nvPr/>
+        </p:nvSpPr>
+        <p:spPr>
+          <a:xfrm>
+            <a:off x="502920" y="6473952"/>
+            <a:ext cx="3657600" cy="274320"/>
+          </a:xfrm>
+          <a:prstGeom prst="rect">
+            <a:avLst/>
+          </a:prstGeom>
+          <a:noFill/>
+        </p:spPr>
+        <p:txBody>
+          <a:bodyPr wrap="square" anchor="t" lIns="0" rIns="0" tIns="0" bIns="0">
+            <a:spAutoFit/>
+          </a:bodyPr>
+          <a:lstStyle/>
+          <a:p>
+            <a:pPr algn="l">
+              <a:lnSpc>
+                <a:spcPct val="100000"/>
+              </a:lnSpc>
+              <a:spcAft>
+                <a:spcPts val="0"/>
+              </a:spcAft>
+            </a:pPr>
+            <a:r>
+              <a:rPr sz="800" b="0" i="0">
+                <a:solidFill>
+                  <a:srgbClr val="6E7A8E"/>
+                </a:solidFill>
+                <a:latin typeface="Calibri"/>
+              </a:rPr>
+              <a:t>COUVERTURE DE CODE — QUARKUS · JUNIT · CUCUMBER · JACOCO</a:t>
+            </a:r>
+          </a:p>
+        </p:txBody>
+      </p:sp>
+    </p:spTree>
+  </p:cSld>
+  <p:clrMapOvr>
+    <a:masterClrMapping/>
+  </p:clrMapOvr>
+</p:sld>
+</file>
+
+<file path=ppt/slides/slide11.xml><?xml version="1.0" encoding="utf-8"?>
+<p:sld xmlns:a="http://schemas.openxmlformats.org/drawingml/2006/main" xmlns:p="http://schemas.openxmlformats.org/presentationml/2006/main" xmlns:r="http://schemas.openxmlformats.org/officeDocument/2006/relationships">
+  <p:cSld>
+    <p:bg>
+      <p:bgPr>
+        <a:solidFill>
+          <a:srgbClr val="0B1D36"/>
+        </a:solidFill>
+        <a:effectLst/>
+      </p:bgPr>
+    </p:bg>
+    <p:spTree>
+      <p:nvGrpSpPr>
+        <p:cNvPr id="1" name=""/>
+        <p:cNvGrpSpPr/>
+        <p:nvPr/>
+      </p:nvGrpSpPr>
+      <p:grpSpPr/>
+      <p:sp>
+        <p:nvSpPr>
           <p:cNvPr id="2" name="Oval 1"/>
           <p:cNvSpPr/>
           <p:nvPr/>
@@ -6961,7 +7534,7 @@
                 </a:solidFill>
                 <a:latin typeface="Calibri"/>
               </a:rPr>
-              <a:t>02 / 10</a:t>
+              <a:t>02 / 11</a:t>
             </a:r>
           </a:p>
         </p:txBody>
@@ -7963,7 +8536,7 @@
                 </a:solidFill>
                 <a:latin typeface="Calibri"/>
               </a:rPr>
-              <a:t>03 / 10</a:t>
+              <a:t>03 / 11</a:t>
             </a:r>
           </a:p>
         </p:txBody>
@@ -9399,7 +9972,7 @@
                 </a:solidFill>
                 <a:latin typeface="Calibri"/>
               </a:rPr>
-              <a:t>04 / 10</a:t>
+              <a:t>04 / 11</a:t>
             </a:r>
           </a:p>
         </p:txBody>
@@ -9898,7 +10471,7 @@
                 </a:solidFill>
                 <a:latin typeface="Calibri"/>
               </a:rPr>
-              <a:t>05 / 10</a:t>
+              <a:t>05 / 11</a:t>
             </a:r>
           </a:p>
         </p:txBody>
@@ -10435,7 +11008,7 @@
                 </a:solidFill>
                 <a:latin typeface="Calibri"/>
               </a:rPr>
-              <a:t>06 / 10</a:t>
+              <a:t>06 / 11</a:t>
             </a:r>
           </a:p>
         </p:txBody>
@@ -12741,7 +13314,7 @@
                 </a:solidFill>
                 <a:latin typeface="Calibri"/>
               </a:rPr>
-              <a:t>07 / 10</a:t>
+              <a:t>07 / 11</a:t>
             </a:r>
           </a:p>
         </p:txBody>
@@ -13489,7 +14062,7 @@
                 </a:solidFill>
                 <a:latin typeface="Calibri"/>
               </a:rPr>
-              <a:t>08 / 10</a:t>
+              <a:t>08 / 11</a:t>
             </a:r>
           </a:p>
         </p:txBody>
@@ -13599,7 +14172,7 @@
                 </a:solidFill>
                 <a:latin typeface="Calibri"/>
               </a:rPr>
-              <a:t>À RETENIR</a:t>
+              <a:t>BONUS</a:t>
             </a:r>
           </a:p>
         </p:txBody>
@@ -13635,13 +14208,13 @@
               </a:spcAft>
             </a:pPr>
             <a:r>
-              <a:rPr sz="3200" b="1" i="0">
+              <a:rPr sz="3000" b="1" i="0">
                 <a:solidFill>
                   <a:srgbClr val="EFECE3"/>
                 </a:solidFill>
                 <a:latin typeface="Calibri"/>
               </a:rPr>
-              <a:t>Ce qu'il faut retenir</a:t>
+              <a:t>Et dans un vrai dashboard ?</a:t>
             </a:r>
           </a:p>
         </p:txBody>
@@ -13654,8 +14227,8 @@
         </p:nvSpPr>
         <p:spPr>
           <a:xfrm>
-            <a:off x="822960" y="2103120"/>
-            <a:ext cx="1097280" cy="1097280"/>
+            <a:off x="822960" y="1536192"/>
+            <a:ext cx="9875520" cy="457200"/>
           </a:xfrm>
           <a:prstGeom prst="rect">
             <a:avLst/>
@@ -13677,27 +14250,543 @@
               </a:spcAft>
             </a:pPr>
             <a:r>
-              <a:rPr sz="3400" b="1" i="0">
-                <a:solidFill>
-                  <a:srgbClr val="C79A52"/>
+              <a:rPr sz="1400" b="0" i="0">
+                <a:solidFill>
+                  <a:srgbClr val="C8CFDA"/>
                 </a:solidFill>
                 <a:latin typeface="Calibri"/>
               </a:rPr>
-              <a:t>01</a:t>
-            </a:r>
-          </a:p>
-        </p:txBody>
-      </p:sp>
-      <p:sp>
-        <p:nvSpPr>
-          <p:cNvPr id="5" name="TextBox 4"/>
+              <a:t>Les deux mêmes rapports Jacoco XML, importés tels quels dans SonarQube.</a:t>
+            </a:r>
+          </a:p>
+        </p:txBody>
+      </p:sp>
+      <p:sp>
+        <p:nvSpPr>
+          <p:cNvPr id="5" name="Rectangle 4"/>
+          <p:cNvSpPr/>
+          <p:nvPr/>
+        </p:nvSpPr>
+        <p:spPr>
+          <a:xfrm>
+            <a:off x="822960" y="2286000"/>
+            <a:ext cx="3310128" cy="1554480"/>
+          </a:xfrm>
+          <a:prstGeom prst="rect">
+            <a:avLst/>
+          </a:prstGeom>
+          <a:solidFill>
+            <a:srgbClr val="183359"/>
+          </a:solidFill>
+          <a:ln>
+            <a:noFill/>
+          </a:ln>
+          <a:effectLst/>
+        </p:spPr>
+        <p:style>
+          <a:lnRef idx="1">
+            <a:schemeClr val="accent1"/>
+          </a:lnRef>
+          <a:fillRef idx="3">
+            <a:schemeClr val="accent1"/>
+          </a:fillRef>
+          <a:effectRef idx="2">
+            <a:schemeClr val="accent1"/>
+          </a:effectRef>
+          <a:fontRef idx="minor">
+            <a:schemeClr val="lt1"/>
+          </a:fontRef>
+        </p:style>
+        <p:txBody>
+          <a:bodyPr rtlCol="0" anchor="ctr"/>
+          <a:lstStyle/>
+          <a:p>
+            <a:pPr algn="ctr"/>
+          </a:p>
+        </p:txBody>
+      </p:sp>
+      <p:sp>
+        <p:nvSpPr>
+          <p:cNvPr id="6" name="Rectangle 5"/>
+          <p:cNvSpPr/>
+          <p:nvPr/>
+        </p:nvSpPr>
+        <p:spPr>
+          <a:xfrm>
+            <a:off x="822960" y="2286000"/>
+            <a:ext cx="3310128" cy="64008"/>
+          </a:xfrm>
+          <a:prstGeom prst="rect">
+            <a:avLst/>
+          </a:prstGeom>
+          <a:solidFill>
+            <a:srgbClr val="C79A52"/>
+          </a:solidFill>
+          <a:ln>
+            <a:noFill/>
+          </a:ln>
+          <a:effectLst/>
+        </p:spPr>
+        <p:style>
+          <a:lnRef idx="1">
+            <a:schemeClr val="accent1"/>
+          </a:lnRef>
+          <a:fillRef idx="3">
+            <a:schemeClr val="accent1"/>
+          </a:fillRef>
+          <a:effectRef idx="2">
+            <a:schemeClr val="accent1"/>
+          </a:effectRef>
+          <a:fontRef idx="minor">
+            <a:schemeClr val="lt1"/>
+          </a:fontRef>
+        </p:style>
+        <p:txBody>
+          <a:bodyPr rtlCol="0" anchor="ctr"/>
+          <a:lstStyle/>
+          <a:p>
+            <a:pPr algn="ctr"/>
+          </a:p>
+        </p:txBody>
+      </p:sp>
+      <p:sp>
+        <p:nvSpPr>
+          <p:cNvPr id="7" name="TextBox 6"/>
           <p:cNvSpPr txBox="1"/>
           <p:nvPr/>
         </p:nvSpPr>
         <p:spPr>
           <a:xfrm>
-            <a:off x="2011680" y="2148840"/>
-            <a:ext cx="8961120" cy="502920"/>
+            <a:off x="822960" y="2542032"/>
+            <a:ext cx="3310128" cy="685800"/>
+          </a:xfrm>
+          <a:prstGeom prst="rect">
+            <a:avLst/>
+          </a:prstGeom>
+          <a:noFill/>
+        </p:spPr>
+        <p:txBody>
+          <a:bodyPr wrap="square" anchor="t" lIns="0" rIns="0" tIns="0" bIns="0">
+            <a:spAutoFit/>
+          </a:bodyPr>
+          <a:lstStyle/>
+          <a:p>
+            <a:pPr algn="ctr">
+              <a:lnSpc>
+                <a:spcPct val="100000"/>
+              </a:lnSpc>
+              <a:spcAft>
+                <a:spcPts val="0"/>
+              </a:spcAft>
+            </a:pPr>
+            <a:r>
+              <a:rPr sz="4000" b="1" i="0">
+                <a:solidFill>
+                  <a:srgbClr val="C79A52"/>
+                </a:solidFill>
+                <a:latin typeface="Calibri"/>
+              </a:rPr>
+              <a:t>77,7 %</a:t>
+            </a:r>
+          </a:p>
+        </p:txBody>
+      </p:sp>
+      <p:sp>
+        <p:nvSpPr>
+          <p:cNvPr id="8" name="TextBox 7"/>
+          <p:cNvSpPr txBox="1"/>
+          <p:nvPr/>
+        </p:nvSpPr>
+        <p:spPr>
+          <a:xfrm>
+            <a:off x="822960" y="3246120"/>
+            <a:ext cx="3310128" cy="365760"/>
+          </a:xfrm>
+          <a:prstGeom prst="rect">
+            <a:avLst/>
+          </a:prstGeom>
+          <a:noFill/>
+        </p:spPr>
+        <p:txBody>
+          <a:bodyPr wrap="square" anchor="t" lIns="0" rIns="0" tIns="0" bIns="0">
+            <a:spAutoFit/>
+          </a:bodyPr>
+          <a:lstStyle/>
+          <a:p>
+            <a:pPr algn="ctr">
+              <a:lnSpc>
+                <a:spcPct val="100000"/>
+              </a:lnSpc>
+              <a:spcAft>
+                <a:spcPts val="0"/>
+              </a:spcAft>
+            </a:pPr>
+            <a:r>
+              <a:rPr sz="1300" b="0" i="0">
+                <a:solidFill>
+                  <a:srgbClr val="8B93A1"/>
+                </a:solidFill>
+                <a:latin typeface="Calibri"/>
+              </a:rPr>
+              <a:t>couverture globale</a:t>
+            </a:r>
+          </a:p>
+        </p:txBody>
+      </p:sp>
+      <p:sp>
+        <p:nvSpPr>
+          <p:cNvPr id="9" name="Rectangle 8"/>
+          <p:cNvSpPr/>
+          <p:nvPr/>
+        </p:nvSpPr>
+        <p:spPr>
+          <a:xfrm>
+            <a:off x="4389120" y="2286000"/>
+            <a:ext cx="3310128" cy="1554480"/>
+          </a:xfrm>
+          <a:prstGeom prst="rect">
+            <a:avLst/>
+          </a:prstGeom>
+          <a:solidFill>
+            <a:srgbClr val="183359"/>
+          </a:solidFill>
+          <a:ln>
+            <a:noFill/>
+          </a:ln>
+          <a:effectLst/>
+        </p:spPr>
+        <p:style>
+          <a:lnRef idx="1">
+            <a:schemeClr val="accent1"/>
+          </a:lnRef>
+          <a:fillRef idx="3">
+            <a:schemeClr val="accent1"/>
+          </a:fillRef>
+          <a:effectRef idx="2">
+            <a:schemeClr val="accent1"/>
+          </a:effectRef>
+          <a:fontRef idx="minor">
+            <a:schemeClr val="lt1"/>
+          </a:fontRef>
+        </p:style>
+        <p:txBody>
+          <a:bodyPr rtlCol="0" anchor="ctr"/>
+          <a:lstStyle/>
+          <a:p>
+            <a:pPr algn="ctr"/>
+          </a:p>
+        </p:txBody>
+      </p:sp>
+      <p:sp>
+        <p:nvSpPr>
+          <p:cNvPr id="10" name="Rectangle 9"/>
+          <p:cNvSpPr/>
+          <p:nvPr/>
+        </p:nvSpPr>
+        <p:spPr>
+          <a:xfrm>
+            <a:off x="4389120" y="2286000"/>
+            <a:ext cx="3310128" cy="64008"/>
+          </a:xfrm>
+          <a:prstGeom prst="rect">
+            <a:avLst/>
+          </a:prstGeom>
+          <a:solidFill>
+            <a:srgbClr val="C79A52"/>
+          </a:solidFill>
+          <a:ln>
+            <a:noFill/>
+          </a:ln>
+          <a:effectLst/>
+        </p:spPr>
+        <p:style>
+          <a:lnRef idx="1">
+            <a:schemeClr val="accent1"/>
+          </a:lnRef>
+          <a:fillRef idx="3">
+            <a:schemeClr val="accent1"/>
+          </a:fillRef>
+          <a:effectRef idx="2">
+            <a:schemeClr val="accent1"/>
+          </a:effectRef>
+          <a:fontRef idx="minor">
+            <a:schemeClr val="lt1"/>
+          </a:fontRef>
+        </p:style>
+        <p:txBody>
+          <a:bodyPr rtlCol="0" anchor="ctr"/>
+          <a:lstStyle/>
+          <a:p>
+            <a:pPr algn="ctr"/>
+          </a:p>
+        </p:txBody>
+      </p:sp>
+      <p:sp>
+        <p:nvSpPr>
+          <p:cNvPr id="11" name="TextBox 10"/>
+          <p:cNvSpPr txBox="1"/>
+          <p:nvPr/>
+        </p:nvSpPr>
+        <p:spPr>
+          <a:xfrm>
+            <a:off x="4389120" y="2542032"/>
+            <a:ext cx="3310128" cy="685800"/>
+          </a:xfrm>
+          <a:prstGeom prst="rect">
+            <a:avLst/>
+          </a:prstGeom>
+          <a:noFill/>
+        </p:spPr>
+        <p:txBody>
+          <a:bodyPr wrap="square" anchor="t" lIns="0" rIns="0" tIns="0" bIns="0">
+            <a:spAutoFit/>
+          </a:bodyPr>
+          <a:lstStyle/>
+          <a:p>
+            <a:pPr algn="ctr">
+              <a:lnSpc>
+                <a:spcPct val="100000"/>
+              </a:lnSpc>
+              <a:spcAft>
+                <a:spcPts val="0"/>
+              </a:spcAft>
+            </a:pPr>
+            <a:r>
+              <a:rPr sz="4000" b="1" i="0">
+                <a:solidFill>
+                  <a:srgbClr val="C79A52"/>
+                </a:solidFill>
+                <a:latin typeface="Calibri"/>
+              </a:rPr>
+              <a:t>82 %</a:t>
+            </a:r>
+          </a:p>
+        </p:txBody>
+      </p:sp>
+      <p:sp>
+        <p:nvSpPr>
+          <p:cNvPr id="12" name="TextBox 11"/>
+          <p:cNvSpPr txBox="1"/>
+          <p:nvPr/>
+        </p:nvSpPr>
+        <p:spPr>
+          <a:xfrm>
+            <a:off x="4389120" y="3246120"/>
+            <a:ext cx="3310128" cy="365760"/>
+          </a:xfrm>
+          <a:prstGeom prst="rect">
+            <a:avLst/>
+          </a:prstGeom>
+          <a:noFill/>
+        </p:spPr>
+        <p:txBody>
+          <a:bodyPr wrap="square" anchor="t" lIns="0" rIns="0" tIns="0" bIns="0">
+            <a:spAutoFit/>
+          </a:bodyPr>
+          <a:lstStyle/>
+          <a:p>
+            <a:pPr algn="ctr">
+              <a:lnSpc>
+                <a:spcPct val="100000"/>
+              </a:lnSpc>
+              <a:spcAft>
+                <a:spcPts val="0"/>
+              </a:spcAft>
+            </a:pPr>
+            <a:r>
+              <a:rPr sz="1300" b="0" i="0">
+                <a:solidFill>
+                  <a:srgbClr val="8B93A1"/>
+                </a:solidFill>
+                <a:latin typeface="Calibri"/>
+              </a:rPr>
+              <a:t>lignes</a:t>
+            </a:r>
+          </a:p>
+        </p:txBody>
+      </p:sp>
+      <p:sp>
+        <p:nvSpPr>
+          <p:cNvPr id="13" name="Rectangle 12"/>
+          <p:cNvSpPr/>
+          <p:nvPr/>
+        </p:nvSpPr>
+        <p:spPr>
+          <a:xfrm>
+            <a:off x="7955280" y="2286000"/>
+            <a:ext cx="3310128" cy="1554480"/>
+          </a:xfrm>
+          <a:prstGeom prst="rect">
+            <a:avLst/>
+          </a:prstGeom>
+          <a:solidFill>
+            <a:srgbClr val="183359"/>
+          </a:solidFill>
+          <a:ln>
+            <a:noFill/>
+          </a:ln>
+          <a:effectLst/>
+        </p:spPr>
+        <p:style>
+          <a:lnRef idx="1">
+            <a:schemeClr val="accent1"/>
+          </a:lnRef>
+          <a:fillRef idx="3">
+            <a:schemeClr val="accent1"/>
+          </a:fillRef>
+          <a:effectRef idx="2">
+            <a:schemeClr val="accent1"/>
+          </a:effectRef>
+          <a:fontRef idx="minor">
+            <a:schemeClr val="lt1"/>
+          </a:fontRef>
+        </p:style>
+        <p:txBody>
+          <a:bodyPr rtlCol="0" anchor="ctr"/>
+          <a:lstStyle/>
+          <a:p>
+            <a:pPr algn="ctr"/>
+          </a:p>
+        </p:txBody>
+      </p:sp>
+      <p:sp>
+        <p:nvSpPr>
+          <p:cNvPr id="14" name="Rectangle 13"/>
+          <p:cNvSpPr/>
+          <p:nvPr/>
+        </p:nvSpPr>
+        <p:spPr>
+          <a:xfrm>
+            <a:off x="7955280" y="2286000"/>
+            <a:ext cx="3310128" cy="64008"/>
+          </a:xfrm>
+          <a:prstGeom prst="rect">
+            <a:avLst/>
+          </a:prstGeom>
+          <a:solidFill>
+            <a:srgbClr val="C79A52"/>
+          </a:solidFill>
+          <a:ln>
+            <a:noFill/>
+          </a:ln>
+          <a:effectLst/>
+        </p:spPr>
+        <p:style>
+          <a:lnRef idx="1">
+            <a:schemeClr val="accent1"/>
+          </a:lnRef>
+          <a:fillRef idx="3">
+            <a:schemeClr val="accent1"/>
+          </a:fillRef>
+          <a:effectRef idx="2">
+            <a:schemeClr val="accent1"/>
+          </a:effectRef>
+          <a:fontRef idx="minor">
+            <a:schemeClr val="lt1"/>
+          </a:fontRef>
+        </p:style>
+        <p:txBody>
+          <a:bodyPr rtlCol="0" anchor="ctr"/>
+          <a:lstStyle/>
+          <a:p>
+            <a:pPr algn="ctr"/>
+          </a:p>
+        </p:txBody>
+      </p:sp>
+      <p:sp>
+        <p:nvSpPr>
+          <p:cNvPr id="15" name="TextBox 14"/>
+          <p:cNvSpPr txBox="1"/>
+          <p:nvPr/>
+        </p:nvSpPr>
+        <p:spPr>
+          <a:xfrm>
+            <a:off x="7955280" y="2542032"/>
+            <a:ext cx="3310128" cy="685800"/>
+          </a:xfrm>
+          <a:prstGeom prst="rect">
+            <a:avLst/>
+          </a:prstGeom>
+          <a:noFill/>
+        </p:spPr>
+        <p:txBody>
+          <a:bodyPr wrap="square" anchor="t" lIns="0" rIns="0" tIns="0" bIns="0">
+            <a:spAutoFit/>
+          </a:bodyPr>
+          <a:lstStyle/>
+          <a:p>
+            <a:pPr algn="ctr">
+              <a:lnSpc>
+                <a:spcPct val="100000"/>
+              </a:lnSpc>
+              <a:spcAft>
+                <a:spcPts val="0"/>
+              </a:spcAft>
+            </a:pPr>
+            <a:r>
+              <a:rPr sz="4000" b="1" i="0">
+                <a:solidFill>
+                  <a:srgbClr val="C79A52"/>
+                </a:solidFill>
+                <a:latin typeface="Calibri"/>
+              </a:rPr>
+              <a:t>65 %</a:t>
+            </a:r>
+          </a:p>
+        </p:txBody>
+      </p:sp>
+      <p:sp>
+        <p:nvSpPr>
+          <p:cNvPr id="16" name="TextBox 15"/>
+          <p:cNvSpPr txBox="1"/>
+          <p:nvPr/>
+        </p:nvSpPr>
+        <p:spPr>
+          <a:xfrm>
+            <a:off x="7955280" y="3246120"/>
+            <a:ext cx="3310128" cy="365760"/>
+          </a:xfrm>
+          <a:prstGeom prst="rect">
+            <a:avLst/>
+          </a:prstGeom>
+          <a:noFill/>
+        </p:spPr>
+        <p:txBody>
+          <a:bodyPr wrap="square" anchor="t" lIns="0" rIns="0" tIns="0" bIns="0">
+            <a:spAutoFit/>
+          </a:bodyPr>
+          <a:lstStyle/>
+          <a:p>
+            <a:pPr algn="ctr">
+              <a:lnSpc>
+                <a:spcPct val="100000"/>
+              </a:lnSpc>
+              <a:spcAft>
+                <a:spcPts val="0"/>
+              </a:spcAft>
+            </a:pPr>
+            <a:r>
+              <a:rPr sz="1300" b="0" i="0">
+                <a:solidFill>
+                  <a:srgbClr val="8B93A1"/>
+                </a:solidFill>
+                <a:latin typeface="Calibri"/>
+              </a:rPr>
+              <a:t>branches</a:t>
+            </a:r>
+          </a:p>
+        </p:txBody>
+      </p:sp>
+      <p:sp>
+        <p:nvSpPr>
+          <p:cNvPr id="17" name="TextBox 16"/>
+          <p:cNvSpPr txBox="1"/>
+          <p:nvPr/>
+        </p:nvSpPr>
+        <p:spPr>
+          <a:xfrm>
+            <a:off x="822960" y="4160520"/>
+            <a:ext cx="9875520" cy="320040"/>
           </a:xfrm>
           <a:prstGeom prst="rect">
             <a:avLst/>
@@ -13719,27 +14808,132 @@
               </a:spcAft>
             </a:pPr>
             <a:r>
-              <a:rPr sz="1800" b="1" i="0">
-                <a:solidFill>
-                  <a:srgbClr val="EFECE3"/>
+              <a:rPr sz="1200" b="0" i="1">
+                <a:solidFill>
+                  <a:srgbClr val="8B93A1"/>
                 </a:solidFill>
                 <a:latin typeface="Calibri"/>
               </a:rPr>
-              <a:t>Un test vert ne dit pas ce qu'il a vérifié.</a:t>
-            </a:r>
-          </a:p>
-        </p:txBody>
-      </p:sp>
-      <p:sp>
-        <p:nvSpPr>
-          <p:cNvPr id="6" name="TextBox 5"/>
+              <a:t>Mesure réelle, obtenue en lançant l'analyse sur ce projet — pas une maquette.</a:t>
+            </a:r>
+          </a:p>
+        </p:txBody>
+      </p:sp>
+      <p:sp>
+        <p:nvSpPr>
+          <p:cNvPr id="18" name="Rectangle 17"/>
+          <p:cNvSpPr/>
+          <p:nvPr/>
+        </p:nvSpPr>
+        <p:spPr>
+          <a:xfrm>
+            <a:off x="822960" y="4617720"/>
+            <a:ext cx="10515600" cy="1051560"/>
+          </a:xfrm>
+          <a:prstGeom prst="rect">
+            <a:avLst/>
+          </a:prstGeom>
+          <a:solidFill>
+            <a:srgbClr val="183359"/>
+          </a:solidFill>
+          <a:ln>
+            <a:noFill/>
+          </a:ln>
+          <a:effectLst/>
+        </p:spPr>
+        <p:style>
+          <a:lnRef idx="1">
+            <a:schemeClr val="accent1"/>
+          </a:lnRef>
+          <a:fillRef idx="3">
+            <a:schemeClr val="accent1"/>
+          </a:fillRef>
+          <a:effectRef idx="2">
+            <a:schemeClr val="accent1"/>
+          </a:effectRef>
+          <a:fontRef idx="minor">
+            <a:schemeClr val="lt1"/>
+          </a:fontRef>
+        </p:style>
+        <p:txBody>
+          <a:bodyPr rtlCol="0" anchor="ctr"/>
+          <a:lstStyle/>
+          <a:p>
+            <a:pPr algn="ctr"/>
+          </a:p>
+        </p:txBody>
+      </p:sp>
+      <p:sp>
+        <p:nvSpPr>
+          <p:cNvPr id="19" name="TextBox 18"/>
           <p:cNvSpPr txBox="1"/>
           <p:nvPr/>
         </p:nvSpPr>
         <p:spPr>
           <a:xfrm>
-            <a:off x="2011680" y="2633472"/>
-            <a:ext cx="8961120" cy="457200"/>
+            <a:off x="1097280" y="4828032"/>
+            <a:ext cx="9966960" cy="640080"/>
+          </a:xfrm>
+          <a:prstGeom prst="rect">
+            <a:avLst/>
+          </a:prstGeom>
+          <a:noFill/>
+        </p:spPr>
+        <p:txBody>
+          <a:bodyPr wrap="square" anchor="t" lIns="0" rIns="0" tIns="0" bIns="0">
+            <a:spAutoFit/>
+          </a:bodyPr>
+          <a:lstStyle/>
+          <a:p>
+            <a:pPr algn="l">
+              <a:lnSpc>
+                <a:spcPct val="130000"/>
+              </a:lnSpc>
+              <a:spcAft>
+                <a:spcPts val="0"/>
+              </a:spcAft>
+            </a:pPr>
+            <a:r>
+              <a:rPr sz="1450" b="0" i="0">
+                <a:solidFill>
+                  <a:srgbClr val="E3E8F0"/>
+                </a:solidFill>
+                <a:latin typeface="Consolas"/>
+              </a:rPr>
+              <a:t>docker compose -f sonarqube/docker-compose.yml up -d</a:t>
+            </a:r>
+          </a:p>
+          <a:p>
+            <a:pPr algn="l">
+              <a:lnSpc>
+                <a:spcPct val="130000"/>
+              </a:lnSpc>
+              <a:spcAft>
+                <a:spcPts val="0"/>
+              </a:spcAft>
+            </a:pPr>
+            <a:r>
+              <a:rPr sz="1450" b="0" i="0">
+                <a:solidFill>
+                  <a:srgbClr val="E3E8F0"/>
+                </a:solidFill>
+                <a:latin typeface="Consolas"/>
+              </a:rPr>
+              <a:t>./mvnw test sonar:sonar -Dsonar.token=&lt;ton_token&gt;</a:t>
+            </a:r>
+          </a:p>
+        </p:txBody>
+      </p:sp>
+      <p:sp>
+        <p:nvSpPr>
+          <p:cNvPr id="20" name="TextBox 19"/>
+          <p:cNvSpPr txBox="1"/>
+          <p:nvPr/>
+        </p:nvSpPr>
+        <p:spPr>
+          <a:xfrm>
+            <a:off x="822960" y="5897880"/>
+            <a:ext cx="9875520" cy="365760"/>
           </a:xfrm>
           <a:prstGeom prst="rect">
             <a:avLst/>
@@ -13761,272 +14955,20 @@
               </a:spcAft>
             </a:pPr>
             <a:r>
-              <a:rPr sz="1400" b="0" i="0">
+              <a:rPr sz="1250" b="0" i="0">
                 <a:solidFill>
                   <a:srgbClr val="8B93A1"/>
                 </a:solidFill>
                 <a:latin typeface="Calibri"/>
               </a:rPr>
-              <a:t>La couverture, si.</a:t>
-            </a:r>
-          </a:p>
-        </p:txBody>
-      </p:sp>
-      <p:sp>
-        <p:nvSpPr>
-          <p:cNvPr id="7" name="TextBox 6"/>
-          <p:cNvSpPr txBox="1"/>
-          <p:nvPr/>
-        </p:nvSpPr>
-        <p:spPr>
-          <a:xfrm>
-            <a:off x="822960" y="3429000"/>
-            <a:ext cx="1097280" cy="1097280"/>
-          </a:xfrm>
-          <a:prstGeom prst="rect">
-            <a:avLst/>
-          </a:prstGeom>
-          <a:noFill/>
-        </p:spPr>
-        <p:txBody>
-          <a:bodyPr wrap="square" anchor="t" lIns="0" rIns="0" tIns="0" bIns="0">
-            <a:spAutoFit/>
-          </a:bodyPr>
-          <a:lstStyle/>
-          <a:p>
-            <a:pPr algn="l">
-              <a:lnSpc>
-                <a:spcPct val="100000"/>
-              </a:lnSpc>
-              <a:spcAft>
-                <a:spcPts val="0"/>
-              </a:spcAft>
-            </a:pPr>
-            <a:r>
-              <a:rPr sz="3400" b="1" i="0">
-                <a:solidFill>
-                  <a:srgbClr val="C79A52"/>
-                </a:solidFill>
-                <a:latin typeface="Calibri"/>
-              </a:rPr>
-              <a:t>02</a:t>
-            </a:r>
-          </a:p>
-        </p:txBody>
-      </p:sp>
-      <p:sp>
-        <p:nvSpPr>
-          <p:cNvPr id="8" name="TextBox 7"/>
-          <p:cNvSpPr txBox="1"/>
-          <p:nvPr/>
-        </p:nvSpPr>
-        <p:spPr>
-          <a:xfrm>
-            <a:off x="2011680" y="3474720"/>
-            <a:ext cx="8961120" cy="502920"/>
-          </a:xfrm>
-          <a:prstGeom prst="rect">
-            <a:avLst/>
-          </a:prstGeom>
-          <a:noFill/>
-        </p:spPr>
-        <p:txBody>
-          <a:bodyPr wrap="square" anchor="t" lIns="0" rIns="0" tIns="0" bIns="0">
-            <a:spAutoFit/>
-          </a:bodyPr>
-          <a:lstStyle/>
-          <a:p>
-            <a:pPr algn="l">
-              <a:lnSpc>
-                <a:spcPct val="100000"/>
-              </a:lnSpc>
-              <a:spcAft>
-                <a:spcPts val="0"/>
-              </a:spcAft>
-            </a:pPr>
-            <a:r>
-              <a:rPr sz="1800" b="1" i="0">
-                <a:solidFill>
-                  <a:srgbClr val="EFECE3"/>
-                </a:solidFill>
-                <a:latin typeface="Calibri"/>
-              </a:rPr>
-              <a:t>JUnit et Cucumber répondent à deux questions différentes.</a:t>
-            </a:r>
-          </a:p>
-        </p:txBody>
-      </p:sp>
-      <p:sp>
-        <p:nvSpPr>
-          <p:cNvPr id="9" name="TextBox 8"/>
-          <p:cNvSpPr txBox="1"/>
-          <p:nvPr/>
-        </p:nvSpPr>
-        <p:spPr>
-          <a:xfrm>
-            <a:off x="2011680" y="3959352"/>
-            <a:ext cx="8961120" cy="457200"/>
-          </a:xfrm>
-          <a:prstGeom prst="rect">
-            <a:avLst/>
-          </a:prstGeom>
-          <a:noFill/>
-        </p:spPr>
-        <p:txBody>
-          <a:bodyPr wrap="square" anchor="t" lIns="0" rIns="0" tIns="0" bIns="0">
-            <a:spAutoFit/>
-          </a:bodyPr>
-          <a:lstStyle/>
-          <a:p>
-            <a:pPr algn="l">
-              <a:lnSpc>
-                <a:spcPct val="100000"/>
-              </a:lnSpc>
-              <a:spcAft>
-                <a:spcPts val="0"/>
-              </a:spcAft>
-            </a:pPr>
-            <a:r>
-              <a:rPr sz="1400" b="0" i="0">
-                <a:solidFill>
-                  <a:srgbClr val="8B93A1"/>
-                </a:solidFill>
-                <a:latin typeface="Calibri"/>
-              </a:rPr>
-              <a:t>« Ça marche ? » contre « c'est le bon comportement ? »</a:t>
-            </a:r>
-          </a:p>
-        </p:txBody>
-      </p:sp>
-      <p:sp>
-        <p:nvSpPr>
-          <p:cNvPr id="10" name="TextBox 9"/>
-          <p:cNvSpPr txBox="1"/>
-          <p:nvPr/>
-        </p:nvSpPr>
-        <p:spPr>
-          <a:xfrm>
-            <a:off x="822960" y="4754880"/>
-            <a:ext cx="1097280" cy="1097280"/>
-          </a:xfrm>
-          <a:prstGeom prst="rect">
-            <a:avLst/>
-          </a:prstGeom>
-          <a:noFill/>
-        </p:spPr>
-        <p:txBody>
-          <a:bodyPr wrap="square" anchor="t" lIns="0" rIns="0" tIns="0" bIns="0">
-            <a:spAutoFit/>
-          </a:bodyPr>
-          <a:lstStyle/>
-          <a:p>
-            <a:pPr algn="l">
-              <a:lnSpc>
-                <a:spcPct val="100000"/>
-              </a:lnSpc>
-              <a:spcAft>
-                <a:spcPts val="0"/>
-              </a:spcAft>
-            </a:pPr>
-            <a:r>
-              <a:rPr sz="3400" b="1" i="0">
-                <a:solidFill>
-                  <a:srgbClr val="C79A52"/>
-                </a:solidFill>
-                <a:latin typeface="Calibri"/>
-              </a:rPr>
-              <a:t>03</a:t>
-            </a:r>
-          </a:p>
-        </p:txBody>
-      </p:sp>
-      <p:sp>
-        <p:nvSpPr>
-          <p:cNvPr id="11" name="TextBox 10"/>
-          <p:cNvSpPr txBox="1"/>
-          <p:nvPr/>
-        </p:nvSpPr>
-        <p:spPr>
-          <a:xfrm>
-            <a:off x="2011680" y="4800600"/>
-            <a:ext cx="8961120" cy="502920"/>
-          </a:xfrm>
-          <a:prstGeom prst="rect">
-            <a:avLst/>
-          </a:prstGeom>
-          <a:noFill/>
-        </p:spPr>
-        <p:txBody>
-          <a:bodyPr wrap="square" anchor="t" lIns="0" rIns="0" tIns="0" bIns="0">
-            <a:spAutoFit/>
-          </a:bodyPr>
-          <a:lstStyle/>
-          <a:p>
-            <a:pPr algn="l">
-              <a:lnSpc>
-                <a:spcPct val="100000"/>
-              </a:lnSpc>
-              <a:spcAft>
-                <a:spcPts val="0"/>
-              </a:spcAft>
-            </a:pPr>
-            <a:r>
-              <a:rPr sz="1800" b="1" i="0">
-                <a:solidFill>
-                  <a:srgbClr val="EFECE3"/>
-                </a:solidFill>
-                <a:latin typeface="Calibri"/>
-              </a:rPr>
-              <a:t>Le rapport de couverture n'est pas un objectif.</a:t>
-            </a:r>
-          </a:p>
-        </p:txBody>
-      </p:sp>
-      <p:sp>
-        <p:nvSpPr>
-          <p:cNvPr id="12" name="TextBox 11"/>
-          <p:cNvSpPr txBox="1"/>
-          <p:nvPr/>
-        </p:nvSpPr>
-        <p:spPr>
-          <a:xfrm>
-            <a:off x="2011680" y="5285232"/>
-            <a:ext cx="8961120" cy="457200"/>
-          </a:xfrm>
-          <a:prstGeom prst="rect">
-            <a:avLst/>
-          </a:prstGeom>
-          <a:noFill/>
-        </p:spPr>
-        <p:txBody>
-          <a:bodyPr wrap="square" anchor="t" lIns="0" rIns="0" tIns="0" bIns="0">
-            <a:spAutoFit/>
-          </a:bodyPr>
-          <a:lstStyle/>
-          <a:p>
-            <a:pPr algn="l">
-              <a:lnSpc>
-                <a:spcPct val="100000"/>
-              </a:lnSpc>
-              <a:spcAft>
-                <a:spcPts val="0"/>
-              </a:spcAft>
-            </a:pPr>
-            <a:r>
-              <a:rPr sz="1400" b="0" i="0">
-                <a:solidFill>
-                  <a:srgbClr val="8B93A1"/>
-                </a:solidFill>
-                <a:latin typeface="Calibri"/>
-              </a:rPr>
-              <a:t>C'est un radar : il montre où regarder en premier.</a:t>
-            </a:r>
-          </a:p>
-        </p:txBody>
-      </p:sp>
-      <p:sp>
-        <p:nvSpPr>
-          <p:cNvPr id="13" name="TextBox 12"/>
+              <a:t>SonarQube Community en local — aucun compte SonarCloud, aucune dépendance réseau pendant le talk.</a:t>
+            </a:r>
+          </a:p>
+        </p:txBody>
+      </p:sp>
+      <p:sp>
+        <p:nvSpPr>
+          <p:cNvPr id="21" name="TextBox 20"/>
           <p:cNvSpPr txBox="1"/>
           <p:nvPr/>
         </p:nvSpPr>
@@ -14061,14 +15003,14 @@
                 </a:solidFill>
                 <a:latin typeface="Calibri"/>
               </a:rPr>
-              <a:t>09 / 10</a:t>
-            </a:r>
-          </a:p>
-        </p:txBody>
-      </p:sp>
-      <p:sp>
-        <p:nvSpPr>
-          <p:cNvPr id="14" name="TextBox 13"/>
+              <a:t>09 / 11</a:t>
+            </a:r>
+          </a:p>
+        </p:txBody>
+      </p:sp>
+      <p:sp>
+        <p:nvSpPr>
+          <p:cNvPr id="22" name="TextBox 21"/>
           <p:cNvSpPr txBox="1"/>
           <p:nvPr/>
         </p:nvSpPr>

</xml_diff>